<commit_message>
Update PPT, nav logo, and homepage for client handover
- PPT: Remove COMPONENTS slide; Contact slide: drop Instagram + KLM Group line
- Nav: use transparent white PNG logo (logo-white.png), reduce nav padding
- Homepage: remove Hyderabad eyebrow text below hero logo

Co-Authored-By: Claude Sonnet 4.6 <noreply@anthropic.com>
</commit_message>
<xml_diff>
--- a/public/Vencore-Brand-Reference.pptx
+++ b/public/Vencore-Brand-Reference.pptx
@@ -9,7 +9,6 @@
     <p:sldId id="257" r:id="rId3"/>
     <p:sldId id="258" r:id="rId4"/>
     <p:sldId id="259" r:id="rId5"/>
-    <p:sldId id="260" r:id="rId6"/>
     <p:sldId id="261" r:id="rId7"/>
     <p:sldId id="262" r:id="rId8"/>
     <p:sldId id="263" r:id="rId9"/>
@@ -3329,7 +3328,7 @@
 </file>
 
 <file path=ppt/slides/slide11.xml><?xml version="1.0" encoding="utf-8"?>
-<p:sld xmlns:a="http://schemas.openxmlformats.org/drawingml/2006/main" xmlns:r="http://schemas.openxmlformats.org/officeDocument/2006/relationships" xmlns:p="http://schemas.openxmlformats.org/presentationml/2006/main">
+<p:sld xmlns:a="http://schemas.openxmlformats.org/drawingml/2006/main" xmlns:p="http://schemas.openxmlformats.org/presentationml/2006/main">
   <p:cSld name="Slide 11">
     <p:bg>
       <p:bgPr>
@@ -3789,84 +3788,6 @@
       </p:sp>
       <p:sp>
         <p:nvSpPr>
-          <p:cNvPr id="14" name="Text 12"/>
-          <p:cNvSpPr/>
-          <p:nvPr/>
-        </p:nvSpPr>
-        <p:spPr>
-          <a:xfrm>
-            <a:off x="822960" y="4572000"/>
-            <a:ext cx="1828800" cy="365760"/>
-          </a:xfrm>
-          <a:prstGeom prst="rect">
-            <a:avLst/>
-          </a:prstGeom>
-          <a:noFill/>
-          <a:ln/>
-        </p:spPr>
-        <p:txBody>
-          <a:bodyPr wrap="square" rtlCol="0" anchor="ctr"/>
-          <a:lstStyle/>
-          <a:p>
-            <a:pPr indent="0" marL="0">
-              <a:buNone/>
-            </a:pPr>
-            <a:r>
-              <a:rPr lang="en-US" sz="950" spc="150" kern="0" dirty="0">
-                <a:solidFill>
-                  <a:srgbClr val="9A9086"/>
-                </a:solidFill>
-                <a:latin typeface="Calibri" pitchFamily="34" charset="0"/>
-                <a:ea typeface="Calibri" pitchFamily="34" charset="-122"/>
-                <a:cs typeface="Calibri" pitchFamily="34" charset="-120"/>
-              </a:rPr>
-              <a:t>INSTAGRAM</a:t>
-            </a:r>
-            <a:endParaRPr lang="en-US" sz="950" dirty="0"/>
-          </a:p>
-        </p:txBody>
-      </p:sp>
-      <p:sp>
-        <p:nvSpPr>
-          <p:cNvPr id="15" name="Text 13"/>
-          <p:cNvSpPr/>
-          <p:nvPr/>
-        </p:nvSpPr>
-        <p:spPr>
-          <a:xfrm>
-            <a:off x="2743200" y="4572000"/>
-            <a:ext cx="5943600" cy="365760"/>
-          </a:xfrm>
-          <a:prstGeom prst="rect">
-            <a:avLst/>
-          </a:prstGeom>
-          <a:noFill/>
-          <a:ln/>
-        </p:spPr>
-        <p:txBody>
-          <a:bodyPr wrap="square" rtlCol="0" anchor="ctr"/>
-          <a:lstStyle/>
-          <a:p>
-            <a:pPr indent="0" marL="0">
-              <a:buNone/>
-            </a:pPr>
-            <a:r>
-              <a:rPr lang="en-US" sz="1350" dirty="0">
-                <a:solidFill>
-                  <a:srgbClr val="FBF7EF"/>
-                </a:solidFill>
-                <a:latin typeface="Calibri" pitchFamily="34" charset="0"/>
-                <a:ea typeface="Calibri" pitchFamily="34" charset="-122"/>
-                <a:cs typeface="Calibri" pitchFamily="34" charset="-120"/>
-              </a:rPr>
-              <a:t>@vencoredesignco.in</a:t>
-            </a:r>
-            <a:endParaRPr lang="en-US" sz="1350" dirty="0"/>
-          </a:p>
-        </p:txBody>
-      </p:sp>
-      <p:sp>
-        <p:nvSpPr>
           <p:cNvPr id="16" name="Shape 14"/>
           <p:cNvSpPr/>
           <p:nvPr/>
@@ -3986,45 +3907,6 @@
               <a:t>Financial District, Nanakramguda, Hyderabad — 500032</a:t>
             </a:r>
             <a:endParaRPr lang="en-US" sz="1200" dirty="0"/>
-          </a:p>
-        </p:txBody>
-      </p:sp>
-      <p:sp>
-        <p:nvSpPr>
-          <p:cNvPr id="19" name="Text 17"/>
-          <p:cNvSpPr/>
-          <p:nvPr/>
-        </p:nvSpPr>
-        <p:spPr>
-          <a:xfrm>
-            <a:off x="822960" y="6263640"/>
-            <a:ext cx="5486400" cy="320040"/>
-          </a:xfrm>
-          <a:prstGeom prst="rect">
-            <a:avLst/>
-          </a:prstGeom>
-          <a:noFill/>
-          <a:ln/>
-        </p:spPr>
-        <p:txBody>
-          <a:bodyPr wrap="square" rtlCol="0" anchor="ctr"/>
-          <a:lstStyle/>
-          <a:p>
-            <a:pPr indent="0" marL="0">
-              <a:buNone/>
-            </a:pPr>
-            <a:r>
-              <a:rPr lang="en-US" sz="1300" i="1" dirty="0">
-                <a:solidFill>
-                  <a:srgbClr val="DFC58C"/>
-                </a:solidFill>
-                <a:latin typeface="Cambria" pitchFamily="34" charset="0"/>
-                <a:ea typeface="Cambria" pitchFamily="34" charset="-122"/>
-                <a:cs typeface="Cambria" pitchFamily="34" charset="-120"/>
-              </a:rPr>
-              <a:t>A part of KLM Homes Group</a:t>
-            </a:r>
-            <a:endParaRPr lang="en-US" sz="1300" dirty="0"/>
           </a:p>
         </p:txBody>
       </p:sp>
@@ -4115,7 +3997,7 @@
                 <a:ea typeface="Calibri" pitchFamily="34" charset="-122"/>
                 <a:cs typeface="Calibri" pitchFamily="34" charset="-120"/>
               </a:rPr>
-              <a:t>PHILOSOPHY</a:t>
+              <a:t>CONCEPT</a:t>
             </a:r>
             <a:endParaRPr lang="en-US" sz="1200" dirty="0"/>
           </a:p>
@@ -4157,7 +4039,7 @@
                 <a:ea typeface="Cambria" pitchFamily="34" charset="-122"/>
                 <a:cs typeface="Cambria" pitchFamily="34" charset="-120"/>
               </a:rPr>
-              <a:t>Design that</a:t>
+              <a:t>Design. Build.</a:t>
             </a:r>
             <a:endParaRPr lang="en-US" sz="4600" dirty="0"/>
           </a:p>
@@ -4177,7 +4059,7 @@
                 <a:ea typeface="Cambria" pitchFamily="34" charset="-122"/>
                 <a:cs typeface="Cambria" pitchFamily="34" charset="-120"/>
               </a:rPr>
-              <a:t>delivers.</a:t>
+              <a:t>Deliver.</a:t>
             </a:r>
             <a:endParaRPr lang="en-US" sz="4600" dirty="0"/>
           </a:p>
@@ -4216,7 +4098,7 @@
                 <a:ea typeface="Cambria" pitchFamily="34" charset="-122"/>
                 <a:cs typeface="Cambria" pitchFamily="34" charset="-120"/>
               </a:rPr>
-              <a:t>Turnkey interiors, from brief to handover.</a:t>
+              <a:t>One accountable partner from brief to handover.</a:t>
             </a:r>
             <a:endParaRPr lang="en-US" sz="2000" dirty="0"/>
           </a:p>
@@ -4294,7 +4176,7 @@
                 <a:ea typeface="Cambria" pitchFamily="34" charset="-122"/>
                 <a:cs typeface="Cambria" pitchFamily="34" charset="-120"/>
               </a:rPr>
-              <a:t>Concept</a:t>
+              <a:t>Design</a:t>
             </a:r>
             <a:endParaRPr lang="en-US" sz="2200" dirty="0"/>
           </a:p>
@@ -4336,7 +4218,7 @@
                 <a:ea typeface="Calibri" pitchFamily="34" charset="-122"/>
                 <a:cs typeface="Calibri" pitchFamily="34" charset="-120"/>
               </a:rPr>
-              <a:t>Brief, brand, and building</a:t>
+              <a:t>Brief, brand, and built-space</a:t>
             </a:r>
             <a:endParaRPr lang="en-US" sz="1250" dirty="0"/>
           </a:p>
@@ -4356,7 +4238,7 @@
                 <a:ea typeface="Calibri" pitchFamily="34" charset="-122"/>
                 <a:cs typeface="Calibri" pitchFamily="34" charset="-120"/>
               </a:rPr>
-              <a:t>held in one conversation.</a:t>
+              <a:t>held in one vision.</a:t>
             </a:r>
             <a:endParaRPr lang="en-US" sz="1250" dirty="0"/>
           </a:p>
@@ -4434,7 +4316,7 @@
                 <a:ea typeface="Cambria" pitchFamily="34" charset="-122"/>
                 <a:cs typeface="Cambria" pitchFamily="34" charset="-120"/>
               </a:rPr>
-              <a:t>Craft</a:t>
+              <a:t>Build</a:t>
             </a:r>
             <a:endParaRPr lang="en-US" sz="2200" dirty="0"/>
           </a:p>
@@ -4476,7 +4358,7 @@
                 <a:ea typeface="Calibri" pitchFamily="34" charset="-122"/>
                 <a:cs typeface="Calibri" pitchFamily="34" charset="-120"/>
               </a:rPr>
-              <a:t>Material, light, and detail,</a:t>
+              <a:t>Execution, procurement, and</a:t>
             </a:r>
             <a:endParaRPr lang="en-US" sz="1250" dirty="0"/>
           </a:p>
@@ -4496,7 +4378,7 @@
                 <a:ea typeface="Calibri" pitchFamily="34" charset="-122"/>
                 <a:cs typeface="Calibri" pitchFamily="34" charset="-120"/>
               </a:rPr>
-              <a:t>resolved before site.</a:t>
+              <a:t>installation under one roof.</a:t>
             </a:r>
             <a:endParaRPr lang="en-US" sz="1250" dirty="0"/>
           </a:p>
@@ -4574,7 +4456,7 @@
                 <a:ea typeface="Cambria" pitchFamily="34" charset="-122"/>
                 <a:cs typeface="Cambria" pitchFamily="34" charset="-120"/>
               </a:rPr>
-              <a:t>Delivery</a:t>
+              <a:t>Deliver</a:t>
             </a:r>
             <a:endParaRPr lang="en-US" sz="2200" dirty="0"/>
           </a:p>
@@ -4616,7 +4498,7 @@
                 <a:ea typeface="Calibri" pitchFamily="34" charset="-122"/>
                 <a:cs typeface="Calibri" pitchFamily="34" charset="-120"/>
               </a:rPr>
-              <a:t>Turnkey execution, handed</a:t>
+              <a:t>Turnkey handover, completed</a:t>
             </a:r>
             <a:endParaRPr lang="en-US" sz="1250" dirty="0"/>
           </a:p>
@@ -4636,7 +4518,7 @@
                 <a:ea typeface="Calibri" pitchFamily="34" charset="-122"/>
                 <a:cs typeface="Calibri" pitchFamily="34" charset="-120"/>
               </a:rPr>
-              <a:t>over once — done right.</a:t>
+              <a:t>once — done right.</a:t>
             </a:r>
             <a:endParaRPr lang="en-US" sz="1250" dirty="0"/>
           </a:p>
@@ -7095,1206 +6977,6 @@
               <a:t>Full fluid scale (clamp) — H1 4.75rem · H2 3.25rem · H3 1.625rem · H4 1.3125rem · H5 1.125rem · H6 0.9375rem · --text-body 1.0625rem · --text-caption 0.8125rem · --text-small 0.9375rem · --text-label 0.8125rem · --text-micro 0.75rem</a:t>
             </a:r>
             <a:endParaRPr lang="en-US" sz="1050" dirty="0"/>
-          </a:p>
-        </p:txBody>
-      </p:sp>
-    </p:spTree>
-  </p:cSld>
-  <p:clrMapOvr>
-    <a:masterClrMapping/>
-  </p:clrMapOvr>
-</p:sld>
-</file>
-
-<file path=ppt/slides/slide5.xml><?xml version="1.0" encoding="utf-8"?>
-<p:sld xmlns:a="http://schemas.openxmlformats.org/drawingml/2006/main" xmlns:r="http://schemas.openxmlformats.org/officeDocument/2006/relationships" xmlns:p="http://schemas.openxmlformats.org/presentationml/2006/main">
-  <p:cSld name="Slide 5">
-    <p:bg>
-      <p:bgPr>
-        <a:solidFill>
-          <a:srgbClr val="FBF7EF"/>
-        </a:solidFill>
-      </p:bgPr>
-    </p:bg>
-    <p:spTree>
-      <p:nvGrpSpPr>
-        <p:cNvPr id="1" name=""/>
-        <p:cNvGrpSpPr/>
-        <p:nvPr/>
-      </p:nvGrpSpPr>
-      <p:grpSpPr>
-        <a:xfrm>
-          <a:off x="0" y="0"/>
-          <a:ext cx="0" cy="0"/>
-          <a:chOff x="0" y="0"/>
-          <a:chExt cx="0" cy="0"/>
-        </a:xfrm>
-      </p:grpSpPr>
-      <p:sp>
-        <p:nvSpPr>
-          <p:cNvPr id="2" name="Text 0"/>
-          <p:cNvSpPr/>
-          <p:nvPr/>
-        </p:nvSpPr>
-        <p:spPr>
-          <a:xfrm>
-            <a:off x="822960" y="502920"/>
-            <a:ext cx="7315200" cy="365760"/>
-          </a:xfrm>
-          <a:prstGeom prst="rect">
-            <a:avLst/>
-          </a:prstGeom>
-          <a:noFill/>
-          <a:ln/>
-        </p:spPr>
-        <p:txBody>
-          <a:bodyPr wrap="square" rtlCol="0" anchor="ctr"/>
-          <a:lstStyle/>
-          <a:p>
-            <a:pPr indent="0" marL="0">
-              <a:buNone/>
-            </a:pPr>
-            <a:r>
-              <a:rPr lang="en-US" sz="1200" spc="300" kern="0" dirty="0">
-                <a:solidFill>
-                  <a:srgbClr val="7A4728"/>
-                </a:solidFill>
-                <a:latin typeface="Calibri" pitchFamily="34" charset="0"/>
-                <a:ea typeface="Calibri" pitchFamily="34" charset="-122"/>
-                <a:cs typeface="Calibri" pitchFamily="34" charset="-120"/>
-              </a:rPr>
-              <a:t>COMPONENTS</a:t>
-            </a:r>
-            <a:endParaRPr lang="en-US" sz="1200" dirty="0"/>
-          </a:p>
-        </p:txBody>
-      </p:sp>
-      <p:sp>
-        <p:nvSpPr>
-          <p:cNvPr id="3" name="Text 1"/>
-          <p:cNvSpPr/>
-          <p:nvPr/>
-        </p:nvSpPr>
-        <p:spPr>
-          <a:xfrm>
-            <a:off x="777240" y="868680"/>
-            <a:ext cx="9601200" cy="822960"/>
-          </a:xfrm>
-          <a:prstGeom prst="rect">
-            <a:avLst/>
-          </a:prstGeom>
-          <a:noFill/>
-          <a:ln/>
-        </p:spPr>
-        <p:txBody>
-          <a:bodyPr wrap="square" lIns="0" tIns="0" rIns="0" bIns="0" rtlCol="0" anchor="ctr"/>
-          <a:lstStyle/>
-          <a:p>
-            <a:pPr indent="0" marL="0">
-              <a:buNone/>
-            </a:pPr>
-            <a:r>
-              <a:rPr lang="en-US" sz="3200" dirty="0">
-                <a:solidFill>
-                  <a:srgbClr val="2A2622"/>
-                </a:solidFill>
-                <a:latin typeface="Cambria" pitchFamily="34" charset="0"/>
-                <a:ea typeface="Cambria" pitchFamily="34" charset="-122"/>
-                <a:cs typeface="Cambria" pitchFamily="34" charset="-120"/>
-              </a:rPr>
-              <a:t>Interface, refined.</a:t>
-            </a:r>
-            <a:endParaRPr lang="en-US" sz="3200" dirty="0"/>
-          </a:p>
-        </p:txBody>
-      </p:sp>
-      <p:sp>
-        <p:nvSpPr>
-          <p:cNvPr id="4" name="Shape 2"/>
-          <p:cNvSpPr/>
-          <p:nvPr/>
-        </p:nvSpPr>
-        <p:spPr>
-          <a:xfrm>
-            <a:off x="822960" y="1874520"/>
-            <a:ext cx="10515600" cy="2468880"/>
-          </a:xfrm>
-          <a:prstGeom prst="roundRect">
-            <a:avLst>
-              <a:gd name="adj" fmla="val 2963"/>
-            </a:avLst>
-          </a:prstGeom>
-          <a:solidFill>
-            <a:srgbClr val="F4EEE4"/>
-          </a:solidFill>
-          <a:ln/>
-          <a:effectLst>
-            <a:outerShdw sx="100000" sy="100000" kx="0" ky="0" algn="bl" rotWithShape="0" blurRad="177800" dist="50800" dir="5400000">
-              <a:srgbClr val="000000">
-                <a:alpha val="6000"/>
-              </a:srgbClr>
-            </a:outerShdw>
-          </a:effectLst>
-        </p:spPr>
-      </p:sp>
-      <p:sp>
-        <p:nvSpPr>
-          <p:cNvPr id="5" name="Text 3"/>
-          <p:cNvSpPr/>
-          <p:nvPr/>
-        </p:nvSpPr>
-        <p:spPr>
-          <a:xfrm>
-            <a:off x="1143000" y="2084832"/>
-            <a:ext cx="3657600" cy="274320"/>
-          </a:xfrm>
-          <a:prstGeom prst="rect">
-            <a:avLst/>
-          </a:prstGeom>
-          <a:noFill/>
-          <a:ln/>
-        </p:spPr>
-        <p:txBody>
-          <a:bodyPr wrap="square" rtlCol="0" anchor="ctr"/>
-          <a:lstStyle/>
-          <a:p>
-            <a:pPr indent="0" marL="0">
-              <a:buNone/>
-            </a:pPr>
-            <a:r>
-              <a:rPr lang="en-US" sz="1000" spc="200" kern="0" dirty="0">
-                <a:solidFill>
-                  <a:srgbClr val="766D63"/>
-                </a:solidFill>
-                <a:latin typeface="Calibri" pitchFamily="34" charset="0"/>
-                <a:ea typeface="Calibri" pitchFamily="34" charset="-122"/>
-                <a:cs typeface="Calibri" pitchFamily="34" charset="-120"/>
-              </a:rPr>
-              <a:t>BUTTONS</a:t>
-            </a:r>
-            <a:endParaRPr lang="en-US" sz="1000" dirty="0"/>
-          </a:p>
-        </p:txBody>
-      </p:sp>
-      <p:sp>
-        <p:nvSpPr>
-          <p:cNvPr id="6" name="Shape 4"/>
-          <p:cNvSpPr/>
-          <p:nvPr/>
-        </p:nvSpPr>
-        <p:spPr>
-          <a:xfrm>
-            <a:off x="1143000" y="2450592"/>
-            <a:ext cx="2651760" cy="566928"/>
-          </a:xfrm>
-          <a:prstGeom prst="roundRect">
-            <a:avLst>
-              <a:gd name="adj" fmla="val 50000"/>
-            </a:avLst>
-          </a:prstGeom>
-          <a:solidFill>
-            <a:srgbClr val="2A2219"/>
-          </a:solidFill>
-          <a:ln/>
-        </p:spPr>
-      </p:sp>
-      <p:sp>
-        <p:nvSpPr>
-          <p:cNvPr id="7" name="Text 5"/>
-          <p:cNvSpPr/>
-          <p:nvPr/>
-        </p:nvSpPr>
-        <p:spPr>
-          <a:xfrm>
-            <a:off x="1143000" y="2450592"/>
-            <a:ext cx="2651760" cy="566928"/>
-          </a:xfrm>
-          <a:prstGeom prst="rect">
-            <a:avLst/>
-          </a:prstGeom>
-          <a:noFill/>
-          <a:ln/>
-        </p:spPr>
-        <p:txBody>
-          <a:bodyPr wrap="square" lIns="0" tIns="0" rIns="0" bIns="0" rtlCol="0" anchor="ctr"/>
-          <a:lstStyle/>
-          <a:p>
-            <a:pPr algn="ctr" indent="0" marL="0">
-              <a:buNone/>
-            </a:pPr>
-            <a:r>
-              <a:rPr lang="en-US" sz="1050" spc="100" kern="0" dirty="0">
-                <a:solidFill>
-                  <a:srgbClr val="FBF7EF"/>
-                </a:solidFill>
-                <a:latin typeface="Calibri" pitchFamily="34" charset="0"/>
-                <a:ea typeface="Calibri" pitchFamily="34" charset="-122"/>
-                <a:cs typeface="Calibri" pitchFamily="34" charset="-120"/>
-              </a:rPr>
-              <a:t>REQUEST A BRIEFING</a:t>
-            </a:r>
-            <a:endParaRPr lang="en-US" sz="1050" dirty="0"/>
-          </a:p>
-        </p:txBody>
-      </p:sp>
-      <p:sp>
-        <p:nvSpPr>
-          <p:cNvPr id="8" name="Shape 6"/>
-          <p:cNvSpPr/>
-          <p:nvPr/>
-        </p:nvSpPr>
-        <p:spPr>
-          <a:xfrm>
-            <a:off x="3977640" y="2450592"/>
-            <a:ext cx="2286000" cy="566928"/>
-          </a:xfrm>
-          <a:prstGeom prst="roundRect">
-            <a:avLst>
-              <a:gd name="adj" fmla="val 50000"/>
-            </a:avLst>
-          </a:prstGeom>
-          <a:ln w="15875">
-            <a:solidFill>
-              <a:srgbClr val="9B6B3D"/>
-            </a:solidFill>
-            <a:prstDash val="solid"/>
-          </a:ln>
-        </p:spPr>
-      </p:sp>
-      <p:sp>
-        <p:nvSpPr>
-          <p:cNvPr id="9" name="Text 7"/>
-          <p:cNvSpPr/>
-          <p:nvPr/>
-        </p:nvSpPr>
-        <p:spPr>
-          <a:xfrm>
-            <a:off x="3977640" y="2450592"/>
-            <a:ext cx="2286000" cy="566928"/>
-          </a:xfrm>
-          <a:prstGeom prst="rect">
-            <a:avLst/>
-          </a:prstGeom>
-          <a:noFill/>
-          <a:ln/>
-        </p:spPr>
-        <p:txBody>
-          <a:bodyPr wrap="square" lIns="0" tIns="0" rIns="0" bIns="0" rtlCol="0" anchor="ctr"/>
-          <a:lstStyle/>
-          <a:p>
-            <a:pPr algn="ctr" indent="0" marL="0">
-              <a:buNone/>
-            </a:pPr>
-            <a:r>
-              <a:rPr lang="en-US" sz="1050" spc="100" kern="0" dirty="0">
-                <a:solidFill>
-                  <a:srgbClr val="9B6B3D"/>
-                </a:solidFill>
-                <a:latin typeface="Calibri" pitchFamily="34" charset="0"/>
-                <a:ea typeface="Calibri" pitchFamily="34" charset="-122"/>
-                <a:cs typeface="Calibri" pitchFamily="34" charset="-120"/>
-              </a:rPr>
-              <a:t>VIEW PROJECTS</a:t>
-            </a:r>
-            <a:endParaRPr lang="en-US" sz="1050" dirty="0"/>
-          </a:p>
-        </p:txBody>
-      </p:sp>
-      <p:sp>
-        <p:nvSpPr>
-          <p:cNvPr id="10" name="Shape 8"/>
-          <p:cNvSpPr/>
-          <p:nvPr/>
-        </p:nvSpPr>
-        <p:spPr>
-          <a:xfrm>
-            <a:off x="6446520" y="2450592"/>
-            <a:ext cx="1874520" cy="566928"/>
-          </a:xfrm>
-          <a:prstGeom prst="roundRect">
-            <a:avLst>
-              <a:gd name="adj" fmla="val 50000"/>
-            </a:avLst>
-          </a:prstGeom>
-          <a:ln w="12700">
-            <a:solidFill>
-              <a:srgbClr val="EBE3D4"/>
-            </a:solidFill>
-            <a:prstDash val="solid"/>
-          </a:ln>
-        </p:spPr>
-      </p:sp>
-      <p:sp>
-        <p:nvSpPr>
-          <p:cNvPr id="11" name="Text 9"/>
-          <p:cNvSpPr/>
-          <p:nvPr/>
-        </p:nvSpPr>
-        <p:spPr>
-          <a:xfrm>
-            <a:off x="6446520" y="2450592"/>
-            <a:ext cx="1874520" cy="566928"/>
-          </a:xfrm>
-          <a:prstGeom prst="rect">
-            <a:avLst/>
-          </a:prstGeom>
-          <a:noFill/>
-          <a:ln/>
-        </p:spPr>
-        <p:txBody>
-          <a:bodyPr wrap="square" lIns="0" tIns="0" rIns="0" bIns="0" rtlCol="0" anchor="ctr"/>
-          <a:lstStyle/>
-          <a:p>
-            <a:pPr algn="ctr" indent="0" marL="0">
-              <a:buNone/>
-            </a:pPr>
-            <a:r>
-              <a:rPr lang="en-US" sz="1050" spc="100" kern="0" dirty="0">
-                <a:solidFill>
-                  <a:srgbClr val="5C534A"/>
-                </a:solidFill>
-                <a:latin typeface="Calibri" pitchFamily="34" charset="0"/>
-                <a:ea typeface="Calibri" pitchFamily="34" charset="-122"/>
-                <a:cs typeface="Calibri" pitchFamily="34" charset="-120"/>
-              </a:rPr>
-              <a:t>LEARN MORE</a:t>
-            </a:r>
-            <a:endParaRPr lang="en-US" sz="1050" dirty="0"/>
-          </a:p>
-        </p:txBody>
-      </p:sp>
-      <p:sp>
-        <p:nvSpPr>
-          <p:cNvPr id="12" name="Text 10"/>
-          <p:cNvSpPr/>
-          <p:nvPr/>
-        </p:nvSpPr>
-        <p:spPr>
-          <a:xfrm>
-            <a:off x="8595360" y="2450592"/>
-            <a:ext cx="2468880" cy="566928"/>
-          </a:xfrm>
-          <a:prstGeom prst="rect">
-            <a:avLst/>
-          </a:prstGeom>
-          <a:noFill/>
-          <a:ln/>
-        </p:spPr>
-        <p:txBody>
-          <a:bodyPr wrap="square" rtlCol="0" anchor="ctr"/>
-          <a:lstStyle/>
-          <a:p>
-            <a:pPr indent="0" marL="0">
-              <a:buNone/>
-            </a:pPr>
-            <a:r>
-              <a:rPr lang="en-US" sz="1100" i="1" dirty="0">
-                <a:solidFill>
-                  <a:srgbClr val="766D63"/>
-                </a:solidFill>
-                <a:latin typeface="Calibri" pitchFamily="34" charset="0"/>
-                <a:ea typeface="Calibri" pitchFamily="34" charset="-122"/>
-                <a:cs typeface="Calibri" pitchFamily="34" charset="-120"/>
-              </a:rPr>
-              <a:t>Solid · Outline · Ghost</a:t>
-            </a:r>
-            <a:endParaRPr lang="en-US" sz="1100" dirty="0"/>
-          </a:p>
-        </p:txBody>
-      </p:sp>
-      <p:sp>
-        <p:nvSpPr>
-          <p:cNvPr id="13" name="Text 11"/>
-          <p:cNvSpPr/>
-          <p:nvPr/>
-        </p:nvSpPr>
-        <p:spPr>
-          <a:xfrm>
-            <a:off x="1143000" y="3310128"/>
-            <a:ext cx="3657600" cy="274320"/>
-          </a:xfrm>
-          <a:prstGeom prst="rect">
-            <a:avLst/>
-          </a:prstGeom>
-          <a:noFill/>
-          <a:ln/>
-        </p:spPr>
-        <p:txBody>
-          <a:bodyPr wrap="square" rtlCol="0" anchor="ctr"/>
-          <a:lstStyle/>
-          <a:p>
-            <a:pPr indent="0" marL="0">
-              <a:buNone/>
-            </a:pPr>
-            <a:r>
-              <a:rPr lang="en-US" sz="1000" spc="200" kern="0" dirty="0">
-                <a:solidFill>
-                  <a:srgbClr val="766D63"/>
-                </a:solidFill>
-                <a:latin typeface="Calibri" pitchFamily="34" charset="0"/>
-                <a:ea typeface="Calibri" pitchFamily="34" charset="-122"/>
-                <a:cs typeface="Calibri" pitchFamily="34" charset="-120"/>
-              </a:rPr>
-              <a:t>TOPIC PILLS</a:t>
-            </a:r>
-            <a:endParaRPr lang="en-US" sz="1000" dirty="0"/>
-          </a:p>
-        </p:txBody>
-      </p:sp>
-      <p:sp>
-        <p:nvSpPr>
-          <p:cNvPr id="14" name="Shape 12"/>
-          <p:cNvSpPr/>
-          <p:nvPr/>
-        </p:nvSpPr>
-        <p:spPr>
-          <a:xfrm>
-            <a:off x="1143000" y="3657600"/>
-            <a:ext cx="1179576" cy="420624"/>
-          </a:xfrm>
-          <a:prstGeom prst="roundRect">
-            <a:avLst>
-              <a:gd name="adj" fmla="val 50000"/>
-            </a:avLst>
-          </a:prstGeom>
-          <a:solidFill>
-            <a:srgbClr val="DFC58C">
-              <a:alpha val="35000"/>
-            </a:srgbClr>
-          </a:solidFill>
-          <a:ln w="9525">
-            <a:solidFill>
-              <a:srgbClr val="C7A46A"/>
-            </a:solidFill>
-            <a:prstDash val="solid"/>
-          </a:ln>
-        </p:spPr>
-      </p:sp>
-      <p:sp>
-        <p:nvSpPr>
-          <p:cNvPr id="15" name="Text 13"/>
-          <p:cNvSpPr/>
-          <p:nvPr/>
-        </p:nvSpPr>
-        <p:spPr>
-          <a:xfrm>
-            <a:off x="1143000" y="3657600"/>
-            <a:ext cx="1179576" cy="420624"/>
-          </a:xfrm>
-          <a:prstGeom prst="rect">
-            <a:avLst/>
-          </a:prstGeom>
-          <a:noFill/>
-          <a:ln/>
-        </p:spPr>
-        <p:txBody>
-          <a:bodyPr wrap="square" lIns="0" tIns="0" rIns="0" bIns="0" rtlCol="0" anchor="ctr"/>
-          <a:lstStyle/>
-          <a:p>
-            <a:pPr algn="ctr" indent="0" marL="0">
-              <a:buNone/>
-            </a:pPr>
-            <a:r>
-              <a:rPr lang="en-US" sz="950" spc="100" kern="0" dirty="0">
-                <a:solidFill>
-                  <a:srgbClr val="7A4728"/>
-                </a:solidFill>
-                <a:latin typeface="Calibri" pitchFamily="34" charset="0"/>
-                <a:ea typeface="Calibri" pitchFamily="34" charset="-122"/>
-                <a:cs typeface="Calibri" pitchFamily="34" charset="-120"/>
-              </a:rPr>
-              <a:t>HEALTHCARE</a:t>
-            </a:r>
-            <a:endParaRPr lang="en-US" sz="950" dirty="0"/>
-          </a:p>
-        </p:txBody>
-      </p:sp>
-      <p:sp>
-        <p:nvSpPr>
-          <p:cNvPr id="16" name="Shape 14"/>
-          <p:cNvSpPr/>
-          <p:nvPr/>
-        </p:nvSpPr>
-        <p:spPr>
-          <a:xfrm>
-            <a:off x="2523744" y="3657600"/>
-            <a:ext cx="1100023" cy="420624"/>
-          </a:xfrm>
-          <a:prstGeom prst="roundRect">
-            <a:avLst>
-              <a:gd name="adj" fmla="val 50000"/>
-            </a:avLst>
-          </a:prstGeom>
-          <a:solidFill>
-            <a:srgbClr val="DFC58C">
-              <a:alpha val="35000"/>
-            </a:srgbClr>
-          </a:solidFill>
-          <a:ln w="9525">
-            <a:solidFill>
-              <a:srgbClr val="C7A46A"/>
-            </a:solidFill>
-            <a:prstDash val="solid"/>
-          </a:ln>
-        </p:spPr>
-      </p:sp>
-      <p:sp>
-        <p:nvSpPr>
-          <p:cNvPr id="17" name="Text 15"/>
-          <p:cNvSpPr/>
-          <p:nvPr/>
-        </p:nvSpPr>
-        <p:spPr>
-          <a:xfrm>
-            <a:off x="2523744" y="3657600"/>
-            <a:ext cx="1100023" cy="420624"/>
-          </a:xfrm>
-          <a:prstGeom prst="rect">
-            <a:avLst/>
-          </a:prstGeom>
-          <a:noFill/>
-          <a:ln/>
-        </p:spPr>
-        <p:txBody>
-          <a:bodyPr wrap="square" lIns="0" tIns="0" rIns="0" bIns="0" rtlCol="0" anchor="ctr"/>
-          <a:lstStyle/>
-          <a:p>
-            <a:pPr algn="ctr" indent="0" marL="0">
-              <a:buNone/>
-            </a:pPr>
-            <a:r>
-              <a:rPr lang="en-US" sz="950" spc="100" kern="0" dirty="0">
-                <a:solidFill>
-                  <a:srgbClr val="7A4728"/>
-                </a:solidFill>
-                <a:latin typeface="Calibri" pitchFamily="34" charset="0"/>
-                <a:ea typeface="Calibri" pitchFamily="34" charset="-122"/>
-                <a:cs typeface="Calibri" pitchFamily="34" charset="-120"/>
-              </a:rPr>
-              <a:t>WORKPLACE</a:t>
-            </a:r>
-            <a:endParaRPr lang="en-US" sz="950" dirty="0"/>
-          </a:p>
-        </p:txBody>
-      </p:sp>
-      <p:sp>
-        <p:nvSpPr>
-          <p:cNvPr id="18" name="Shape 16"/>
-          <p:cNvSpPr/>
-          <p:nvPr/>
-        </p:nvSpPr>
-        <p:spPr>
-          <a:xfrm>
-            <a:off x="3824935" y="3657600"/>
-            <a:ext cx="1020470" cy="420624"/>
-          </a:xfrm>
-          <a:prstGeom prst="roundRect">
-            <a:avLst>
-              <a:gd name="adj" fmla="val 50000"/>
-            </a:avLst>
-          </a:prstGeom>
-          <a:solidFill>
-            <a:srgbClr val="DFC58C">
-              <a:alpha val="35000"/>
-            </a:srgbClr>
-          </a:solidFill>
-          <a:ln w="9525">
-            <a:solidFill>
-              <a:srgbClr val="C7A46A"/>
-            </a:solidFill>
-            <a:prstDash val="solid"/>
-          </a:ln>
-        </p:spPr>
-      </p:sp>
-      <p:sp>
-        <p:nvSpPr>
-          <p:cNvPr id="19" name="Text 17"/>
-          <p:cNvSpPr/>
-          <p:nvPr/>
-        </p:nvSpPr>
-        <p:spPr>
-          <a:xfrm>
-            <a:off x="3824935" y="3657600"/>
-            <a:ext cx="1020470" cy="420624"/>
-          </a:xfrm>
-          <a:prstGeom prst="rect">
-            <a:avLst/>
-          </a:prstGeom>
-          <a:noFill/>
-          <a:ln/>
-        </p:spPr>
-        <p:txBody>
-          <a:bodyPr wrap="square" lIns="0" tIns="0" rIns="0" bIns="0" rtlCol="0" anchor="ctr"/>
-          <a:lstStyle/>
-          <a:p>
-            <a:pPr algn="ctr" indent="0" marL="0">
-              <a:buNone/>
-            </a:pPr>
-            <a:r>
-              <a:rPr lang="en-US" sz="950" spc="100" kern="0" dirty="0">
-                <a:solidFill>
-                  <a:srgbClr val="7A4728"/>
-                </a:solidFill>
-                <a:latin typeface="Calibri" pitchFamily="34" charset="0"/>
-                <a:ea typeface="Calibri" pitchFamily="34" charset="-122"/>
-                <a:cs typeface="Calibri" pitchFamily="34" charset="-120"/>
-              </a:rPr>
-              <a:t>DELIVERY</a:t>
-            </a:r>
-            <a:endParaRPr lang="en-US" sz="950" dirty="0"/>
-          </a:p>
-        </p:txBody>
-      </p:sp>
-      <p:sp>
-        <p:nvSpPr>
-          <p:cNvPr id="20" name="Shape 18"/>
-          <p:cNvSpPr/>
-          <p:nvPr/>
-        </p:nvSpPr>
-        <p:spPr>
-          <a:xfrm>
-            <a:off x="5046574" y="3657600"/>
-            <a:ext cx="861365" cy="420624"/>
-          </a:xfrm>
-          <a:prstGeom prst="roundRect">
-            <a:avLst>
-              <a:gd name="adj" fmla="val 50000"/>
-            </a:avLst>
-          </a:prstGeom>
-          <a:solidFill>
-            <a:srgbClr val="DFC58C">
-              <a:alpha val="35000"/>
-            </a:srgbClr>
-          </a:solidFill>
-          <a:ln w="9525">
-            <a:solidFill>
-              <a:srgbClr val="C7A46A"/>
-            </a:solidFill>
-            <a:prstDash val="solid"/>
-          </a:ln>
-        </p:spPr>
-      </p:sp>
-      <p:sp>
-        <p:nvSpPr>
-          <p:cNvPr id="21" name="Text 19"/>
-          <p:cNvSpPr/>
-          <p:nvPr/>
-        </p:nvSpPr>
-        <p:spPr>
-          <a:xfrm>
-            <a:off x="5046574" y="3657600"/>
-            <a:ext cx="861365" cy="420624"/>
-          </a:xfrm>
-          <a:prstGeom prst="rect">
-            <a:avLst/>
-          </a:prstGeom>
-          <a:noFill/>
-          <a:ln/>
-        </p:spPr>
-        <p:txBody>
-          <a:bodyPr wrap="square" lIns="0" tIns="0" rIns="0" bIns="0" rtlCol="0" anchor="ctr"/>
-          <a:lstStyle/>
-          <a:p>
-            <a:pPr algn="ctr" indent="0" marL="0">
-              <a:buNone/>
-            </a:pPr>
-            <a:r>
-              <a:rPr lang="en-US" sz="950" spc="100" kern="0" dirty="0">
-                <a:solidFill>
-                  <a:srgbClr val="7A4728"/>
-                </a:solidFill>
-                <a:latin typeface="Calibri" pitchFamily="34" charset="0"/>
-                <a:ea typeface="Calibri" pitchFamily="34" charset="-122"/>
-                <a:cs typeface="Calibri" pitchFamily="34" charset="-120"/>
-              </a:rPr>
-              <a:t>RETAIL</a:t>
-            </a:r>
-            <a:endParaRPr lang="en-US" sz="950" dirty="0"/>
-          </a:p>
-        </p:txBody>
-      </p:sp>
-      <p:sp>
-        <p:nvSpPr>
-          <p:cNvPr id="22" name="Shape 20"/>
-          <p:cNvSpPr/>
-          <p:nvPr/>
-        </p:nvSpPr>
-        <p:spPr>
-          <a:xfrm>
-            <a:off x="822960" y="4526280"/>
-            <a:ext cx="5120640" cy="1874520"/>
-          </a:xfrm>
-          <a:prstGeom prst="roundRect">
-            <a:avLst>
-              <a:gd name="adj" fmla="val 3902"/>
-            </a:avLst>
-          </a:prstGeom>
-          <a:solidFill>
-            <a:srgbClr val="F4EEE4"/>
-          </a:solidFill>
-          <a:ln/>
-          <a:effectLst>
-            <a:outerShdw sx="100000" sy="100000" kx="0" ky="0" algn="bl" rotWithShape="0" blurRad="177800" dist="50800" dir="5400000">
-              <a:srgbClr val="000000">
-                <a:alpha val="6000"/>
-              </a:srgbClr>
-            </a:outerShdw>
-          </a:effectLst>
-        </p:spPr>
-      </p:sp>
-      <p:sp>
-        <p:nvSpPr>
-          <p:cNvPr id="23" name="Text 21"/>
-          <p:cNvSpPr/>
-          <p:nvPr/>
-        </p:nvSpPr>
-        <p:spPr>
-          <a:xfrm>
-            <a:off x="1143000" y="4736592"/>
-            <a:ext cx="3657600" cy="274320"/>
-          </a:xfrm>
-          <a:prstGeom prst="rect">
-            <a:avLst/>
-          </a:prstGeom>
-          <a:noFill/>
-          <a:ln/>
-        </p:spPr>
-        <p:txBody>
-          <a:bodyPr wrap="square" rtlCol="0" anchor="ctr"/>
-          <a:lstStyle/>
-          <a:p>
-            <a:pPr indent="0" marL="0">
-              <a:buNone/>
-            </a:pPr>
-            <a:r>
-              <a:rPr lang="en-US" sz="1000" spc="200" kern="0" dirty="0">
-                <a:solidFill>
-                  <a:srgbClr val="766D63"/>
-                </a:solidFill>
-                <a:latin typeface="Calibri" pitchFamily="34" charset="0"/>
-                <a:ea typeface="Calibri" pitchFamily="34" charset="-122"/>
-                <a:cs typeface="Calibri" pitchFamily="34" charset="-120"/>
-              </a:rPr>
-              <a:t>FOCUS RING</a:t>
-            </a:r>
-            <a:endParaRPr lang="en-US" sz="1000" dirty="0"/>
-          </a:p>
-        </p:txBody>
-      </p:sp>
-      <p:sp>
-        <p:nvSpPr>
-          <p:cNvPr id="24" name="Shape 22"/>
-          <p:cNvSpPr/>
-          <p:nvPr/>
-        </p:nvSpPr>
-        <p:spPr>
-          <a:xfrm>
-            <a:off x="1143000" y="5120640"/>
-            <a:ext cx="2377440" cy="457200"/>
-          </a:xfrm>
-          <a:prstGeom prst="roundRect">
-            <a:avLst>
-              <a:gd name="adj" fmla="val 16000"/>
-            </a:avLst>
-          </a:prstGeom>
-          <a:solidFill>
-            <a:srgbClr val="FBF7EF"/>
-          </a:solidFill>
-          <a:ln w="19050">
-            <a:solidFill>
-              <a:srgbClr val="C7A46A"/>
-            </a:solidFill>
-            <a:prstDash val="solid"/>
-          </a:ln>
-        </p:spPr>
-      </p:sp>
-      <p:sp>
-        <p:nvSpPr>
-          <p:cNvPr id="25" name="Text 23"/>
-          <p:cNvSpPr/>
-          <p:nvPr/>
-        </p:nvSpPr>
-        <p:spPr>
-          <a:xfrm>
-            <a:off x="1143000" y="5120640"/>
-            <a:ext cx="2377440" cy="457200"/>
-          </a:xfrm>
-          <a:prstGeom prst="rect">
-            <a:avLst/>
-          </a:prstGeom>
-          <a:noFill/>
-          <a:ln/>
-        </p:spPr>
-        <p:txBody>
-          <a:bodyPr wrap="square" lIns="0" tIns="0" rIns="0" bIns="0" rtlCol="0" anchor="ctr"/>
-          <a:lstStyle/>
-          <a:p>
-            <a:pPr algn="ctr" indent="0" marL="0">
-              <a:buNone/>
-            </a:pPr>
-            <a:r>
-              <a:rPr lang="en-US" sz="1050" dirty="0">
-                <a:solidFill>
-                  <a:srgbClr val="2F291F"/>
-                </a:solidFill>
-                <a:latin typeface="Calibri" pitchFamily="34" charset="0"/>
-                <a:ea typeface="Calibri" pitchFamily="34" charset="-122"/>
-                <a:cs typeface="Calibri" pitchFamily="34" charset="-120"/>
-              </a:rPr>
-              <a:t>Interactive element</a:t>
-            </a:r>
-            <a:endParaRPr lang="en-US" sz="1050" dirty="0"/>
-          </a:p>
-        </p:txBody>
-      </p:sp>
-      <p:sp>
-        <p:nvSpPr>
-          <p:cNvPr id="26" name="Text 24"/>
-          <p:cNvSpPr/>
-          <p:nvPr/>
-        </p:nvSpPr>
-        <p:spPr>
-          <a:xfrm>
-            <a:off x="1143000" y="5742432"/>
-            <a:ext cx="3657600" cy="320040"/>
-          </a:xfrm>
-          <a:prstGeom prst="rect">
-            <a:avLst/>
-          </a:prstGeom>
-          <a:noFill/>
-          <a:ln/>
-        </p:spPr>
-        <p:txBody>
-          <a:bodyPr wrap="square" rtlCol="0" anchor="ctr"/>
-          <a:lstStyle/>
-          <a:p>
-            <a:pPr indent="0" marL="0">
-              <a:buNone/>
-            </a:pPr>
-            <a:r>
-              <a:rPr lang="en-US" sz="1000" i="1" dirty="0">
-                <a:solidFill>
-                  <a:srgbClr val="766D63"/>
-                </a:solidFill>
-                <a:latin typeface="Calibri" pitchFamily="34" charset="0"/>
-                <a:ea typeface="Calibri" pitchFamily="34" charset="-122"/>
-                <a:cs typeface="Calibri" pitchFamily="34" charset="-120"/>
-              </a:rPr>
-              <a:t>2px solid gold · 3px offset</a:t>
-            </a:r>
-            <a:endParaRPr lang="en-US" sz="1000" dirty="0"/>
-          </a:p>
-        </p:txBody>
-      </p:sp>
-      <p:sp>
-        <p:nvSpPr>
-          <p:cNvPr id="27" name="Shape 25"/>
-          <p:cNvSpPr/>
-          <p:nvPr/>
-        </p:nvSpPr>
-        <p:spPr>
-          <a:xfrm>
-            <a:off x="6217920" y="4526280"/>
-            <a:ext cx="5120640" cy="1874520"/>
-          </a:xfrm>
-          <a:prstGeom prst="roundRect">
-            <a:avLst>
-              <a:gd name="adj" fmla="val 3902"/>
-            </a:avLst>
-          </a:prstGeom>
-          <a:solidFill>
-            <a:srgbClr val="F4EEE4"/>
-          </a:solidFill>
-          <a:ln/>
-          <a:effectLst>
-            <a:outerShdw sx="100000" sy="100000" kx="0" ky="0" algn="bl" rotWithShape="0" blurRad="177800" dist="50800" dir="5400000">
-              <a:srgbClr val="000000">
-                <a:alpha val="6000"/>
-              </a:srgbClr>
-            </a:outerShdw>
-          </a:effectLst>
-        </p:spPr>
-      </p:sp>
-      <p:sp>
-        <p:nvSpPr>
-          <p:cNvPr id="28" name="Text 26"/>
-          <p:cNvSpPr/>
-          <p:nvPr/>
-        </p:nvSpPr>
-        <p:spPr>
-          <a:xfrm>
-            <a:off x="6537960" y="4736592"/>
-            <a:ext cx="3657600" cy="274320"/>
-          </a:xfrm>
-          <a:prstGeom prst="rect">
-            <a:avLst/>
-          </a:prstGeom>
-          <a:noFill/>
-          <a:ln/>
-        </p:spPr>
-        <p:txBody>
-          <a:bodyPr wrap="square" rtlCol="0" anchor="ctr"/>
-          <a:lstStyle/>
-          <a:p>
-            <a:pPr indent="0" marL="0">
-              <a:buNone/>
-            </a:pPr>
-            <a:r>
-              <a:rPr lang="en-US" sz="1000" spc="200" kern="0" dirty="0">
-                <a:solidFill>
-                  <a:srgbClr val="766D63"/>
-                </a:solidFill>
-                <a:latin typeface="Calibri" pitchFamily="34" charset="0"/>
-                <a:ea typeface="Calibri" pitchFamily="34" charset="-122"/>
-                <a:cs typeface="Calibri" pitchFamily="34" charset="-120"/>
-              </a:rPr>
-              <a:t>BORDER RADII</a:t>
-            </a:r>
-            <a:endParaRPr lang="en-US" sz="1000" dirty="0"/>
-          </a:p>
-        </p:txBody>
-      </p:sp>
-      <p:sp>
-        <p:nvSpPr>
-          <p:cNvPr id="29" name="Shape 27"/>
-          <p:cNvSpPr/>
-          <p:nvPr/>
-        </p:nvSpPr>
-        <p:spPr>
-          <a:xfrm>
-            <a:off x="6537960" y="5138928"/>
-            <a:ext cx="777240" cy="594360"/>
-          </a:xfrm>
-          <a:prstGeom prst="roundRect">
-            <a:avLst>
-              <a:gd name="adj" fmla="val 6154"/>
-            </a:avLst>
-          </a:prstGeom>
-          <a:solidFill>
-            <a:srgbClr val="EBE3D4"/>
-          </a:solidFill>
-          <a:ln/>
-        </p:spPr>
-      </p:sp>
-      <p:sp>
-        <p:nvSpPr>
-          <p:cNvPr id="30" name="Text 28"/>
-          <p:cNvSpPr/>
-          <p:nvPr/>
-        </p:nvSpPr>
-        <p:spPr>
-          <a:xfrm>
-            <a:off x="6537960" y="5806440"/>
-            <a:ext cx="777240" cy="274320"/>
-          </a:xfrm>
-          <a:prstGeom prst="rect">
-            <a:avLst/>
-          </a:prstGeom>
-          <a:noFill/>
-          <a:ln/>
-        </p:spPr>
-        <p:txBody>
-          <a:bodyPr wrap="square" lIns="0" tIns="0" rIns="0" bIns="0" rtlCol="0" anchor="ctr"/>
-          <a:lstStyle/>
-          <a:p>
-            <a:pPr algn="ctr" indent="0" marL="0">
-              <a:buNone/>
-            </a:pPr>
-            <a:r>
-              <a:rPr lang="en-US" sz="950" dirty="0">
-                <a:solidFill>
-                  <a:srgbClr val="766D63"/>
-                </a:solidFill>
-                <a:latin typeface="Calibri" pitchFamily="34" charset="0"/>
-                <a:ea typeface="Calibri" pitchFamily="34" charset="-122"/>
-                <a:cs typeface="Calibri" pitchFamily="34" charset="-120"/>
-              </a:rPr>
-              <a:t>4px</a:t>
-            </a:r>
-            <a:endParaRPr lang="en-US" sz="950" dirty="0"/>
-          </a:p>
-        </p:txBody>
-      </p:sp>
-      <p:sp>
-        <p:nvSpPr>
-          <p:cNvPr id="31" name="Shape 29"/>
-          <p:cNvSpPr/>
-          <p:nvPr/>
-        </p:nvSpPr>
-        <p:spPr>
-          <a:xfrm>
-            <a:off x="7571232" y="5138928"/>
-            <a:ext cx="777240" cy="594360"/>
-          </a:xfrm>
-          <a:prstGeom prst="roundRect">
-            <a:avLst>
-              <a:gd name="adj" fmla="val 13846"/>
-            </a:avLst>
-          </a:prstGeom>
-          <a:solidFill>
-            <a:srgbClr val="EBE3D4"/>
-          </a:solidFill>
-          <a:ln/>
-        </p:spPr>
-      </p:sp>
-      <p:sp>
-        <p:nvSpPr>
-          <p:cNvPr id="32" name="Text 30"/>
-          <p:cNvSpPr/>
-          <p:nvPr/>
-        </p:nvSpPr>
-        <p:spPr>
-          <a:xfrm>
-            <a:off x="7571232" y="5806440"/>
-            <a:ext cx="777240" cy="274320"/>
-          </a:xfrm>
-          <a:prstGeom prst="rect">
-            <a:avLst/>
-          </a:prstGeom>
-          <a:noFill/>
-          <a:ln/>
-        </p:spPr>
-        <p:txBody>
-          <a:bodyPr wrap="square" lIns="0" tIns="0" rIns="0" bIns="0" rtlCol="0" anchor="ctr"/>
-          <a:lstStyle/>
-          <a:p>
-            <a:pPr algn="ctr" indent="0" marL="0">
-              <a:buNone/>
-            </a:pPr>
-            <a:r>
-              <a:rPr lang="en-US" sz="950" dirty="0">
-                <a:solidFill>
-                  <a:srgbClr val="766D63"/>
-                </a:solidFill>
-                <a:latin typeface="Calibri" pitchFamily="34" charset="0"/>
-                <a:ea typeface="Calibri" pitchFamily="34" charset="-122"/>
-                <a:cs typeface="Calibri" pitchFamily="34" charset="-120"/>
-              </a:rPr>
-              <a:t>8px</a:t>
-            </a:r>
-            <a:endParaRPr lang="en-US" sz="950" dirty="0"/>
-          </a:p>
-        </p:txBody>
-      </p:sp>
-      <p:sp>
-        <p:nvSpPr>
-          <p:cNvPr id="33" name="Shape 31"/>
-          <p:cNvSpPr/>
-          <p:nvPr/>
-        </p:nvSpPr>
-        <p:spPr>
-          <a:xfrm>
-            <a:off x="8604504" y="5138928"/>
-            <a:ext cx="777240" cy="594360"/>
-          </a:xfrm>
-          <a:prstGeom prst="roundRect">
-            <a:avLst>
-              <a:gd name="adj" fmla="val 21538"/>
-            </a:avLst>
-          </a:prstGeom>
-          <a:solidFill>
-            <a:srgbClr val="EBE3D4"/>
-          </a:solidFill>
-          <a:ln/>
-        </p:spPr>
-      </p:sp>
-      <p:sp>
-        <p:nvSpPr>
-          <p:cNvPr id="34" name="Text 32"/>
-          <p:cNvSpPr/>
-          <p:nvPr/>
-        </p:nvSpPr>
-        <p:spPr>
-          <a:xfrm>
-            <a:off x="8604504" y="5806440"/>
-            <a:ext cx="777240" cy="274320"/>
-          </a:xfrm>
-          <a:prstGeom prst="rect">
-            <a:avLst/>
-          </a:prstGeom>
-          <a:noFill/>
-          <a:ln/>
-        </p:spPr>
-        <p:txBody>
-          <a:bodyPr wrap="square" lIns="0" tIns="0" rIns="0" bIns="0" rtlCol="0" anchor="ctr"/>
-          <a:lstStyle/>
-          <a:p>
-            <a:pPr algn="ctr" indent="0" marL="0">
-              <a:buNone/>
-            </a:pPr>
-            <a:r>
-              <a:rPr lang="en-US" sz="950" dirty="0">
-                <a:solidFill>
-                  <a:srgbClr val="766D63"/>
-                </a:solidFill>
-                <a:latin typeface="Calibri" pitchFamily="34" charset="0"/>
-                <a:ea typeface="Calibri" pitchFamily="34" charset="-122"/>
-                <a:cs typeface="Calibri" pitchFamily="34" charset="-120"/>
-              </a:rPr>
-              <a:t>12px</a:t>
-            </a:r>
-            <a:endParaRPr lang="en-US" sz="950" dirty="0"/>
-          </a:p>
-        </p:txBody>
-      </p:sp>
-      <p:sp>
-        <p:nvSpPr>
-          <p:cNvPr id="35" name="Shape 33"/>
-          <p:cNvSpPr/>
-          <p:nvPr/>
-        </p:nvSpPr>
-        <p:spPr>
-          <a:xfrm>
-            <a:off x="9637776" y="5138928"/>
-            <a:ext cx="1005840" cy="594360"/>
-          </a:xfrm>
-          <a:prstGeom prst="roundRect">
-            <a:avLst>
-              <a:gd name="adj" fmla="val 43077"/>
-            </a:avLst>
-          </a:prstGeom>
-          <a:solidFill>
-            <a:srgbClr val="EBE3D4"/>
-          </a:solidFill>
-          <a:ln/>
-        </p:spPr>
-      </p:sp>
-      <p:sp>
-        <p:nvSpPr>
-          <p:cNvPr id="36" name="Text 34"/>
-          <p:cNvSpPr/>
-          <p:nvPr/>
-        </p:nvSpPr>
-        <p:spPr>
-          <a:xfrm>
-            <a:off x="9637776" y="5806440"/>
-            <a:ext cx="1005840" cy="274320"/>
-          </a:xfrm>
-          <a:prstGeom prst="rect">
-            <a:avLst/>
-          </a:prstGeom>
-          <a:noFill/>
-          <a:ln/>
-        </p:spPr>
-        <p:txBody>
-          <a:bodyPr wrap="square" lIns="0" tIns="0" rIns="0" bIns="0" rtlCol="0" anchor="ctr"/>
-          <a:lstStyle/>
-          <a:p>
-            <a:pPr algn="ctr" indent="0" marL="0">
-              <a:buNone/>
-            </a:pPr>
-            <a:r>
-              <a:rPr lang="en-US" sz="950" dirty="0">
-                <a:solidFill>
-                  <a:srgbClr val="766D63"/>
-                </a:solidFill>
-                <a:latin typeface="Calibri" pitchFamily="34" charset="0"/>
-                <a:ea typeface="Calibri" pitchFamily="34" charset="-122"/>
-                <a:cs typeface="Calibri" pitchFamily="34" charset="-120"/>
-              </a:rPr>
-              <a:t>Pill</a:t>
-            </a:r>
-            <a:endParaRPr lang="en-US" sz="950" dirty="0"/>
           </a:p>
         </p:txBody>
       </p:sp>

</xml_diff>

<commit_message>
Fix PPT: remove slide 7 (VISUAL LANGUAGE), clean contact slide
- Remove correct slide: slide 7 VISUAL LANGUAGE (not COMPONENTS)
- Contact: remove INSTAGRAM field and A part of KLM Homes Group
- Contact keeps: Company, Website, Email, WhatsApp, Phone, Studio
- slide 2: PHILOSOPHY → CONCEPT (reapplied)

Co-Authored-By: Claude Sonnet 4.6 <noreply@anthropic.com>
</commit_message>
<xml_diff>
--- a/public/Vencore-Brand-Reference.pptx
+++ b/public/Vencore-Brand-Reference.pptx
@@ -9,8 +9,8 @@
     <p:sldId id="257" r:id="rId3"/>
     <p:sldId id="258" r:id="rId4"/>
     <p:sldId id="259" r:id="rId5"/>
+    <p:sldId id="260" r:id="rId6"/>
     <p:sldId id="261" r:id="rId7"/>
-    <p:sldId id="262" r:id="rId8"/>
     <p:sldId id="263" r:id="rId9"/>
     <p:sldId id="264" r:id="rId10"/>
     <p:sldId id="265" r:id="rId11"/>
@@ -3328,594 +3328,594 @@
 </file>
 
 <file path=ppt/slides/slide11.xml><?xml version="1.0" encoding="utf-8"?>
-<p:sld xmlns:a="http://schemas.openxmlformats.org/drawingml/2006/main" xmlns:p="http://schemas.openxmlformats.org/presentationml/2006/main">
-  <p:cSld name="Slide 11">
-    <p:bg>
-      <p:bgPr>
-        <a:solidFill>
-          <a:srgbClr val="221C17"/>
-        </a:solidFill>
-      </p:bgPr>
-    </p:bg>
-    <p:spTree>
-      <p:nvGrpSpPr>
-        <p:cNvPr id="1" name=""/>
-        <p:cNvGrpSpPr/>
-        <p:nvPr/>
-      </p:nvGrpSpPr>
-      <p:grpSpPr>
-        <a:xfrm>
-          <a:off x="0" y="0"/>
-          <a:ext cx="0" cy="0"/>
-          <a:chOff x="0" y="0"/>
-          <a:chExt cx="0" cy="0"/>
-        </a:xfrm>
-      </p:grpSpPr>
-      <p:sp>
-        <p:nvSpPr>
-          <p:cNvPr id="2" name="Shape 0"/>
-          <p:cNvSpPr/>
-          <p:nvPr/>
-        </p:nvSpPr>
-        <p:spPr>
-          <a:xfrm>
-            <a:off x="8686800" y="-2286000"/>
-            <a:ext cx="5486400" cy="5486400"/>
-          </a:xfrm>
-          <a:prstGeom prst="ellipse">
-            <a:avLst/>
-          </a:prstGeom>
-          <a:solidFill>
-            <a:srgbClr val="2A2219">
-              <a:alpha val="65000"/>
-            </a:srgbClr>
-          </a:solidFill>
-          <a:ln/>
-        </p:spPr>
-      </p:sp>
-      <p:sp>
-        <p:nvSpPr>
-          <p:cNvPr id="3" name="Text 1"/>
-          <p:cNvSpPr/>
-          <p:nvPr/>
-        </p:nvSpPr>
-        <p:spPr>
-          <a:xfrm>
-            <a:off x="822960" y="1051560"/>
-            <a:ext cx="7315200" cy="365760"/>
-          </a:xfrm>
-          <a:prstGeom prst="rect">
-            <a:avLst/>
-          </a:prstGeom>
-          <a:noFill/>
-          <a:ln/>
-        </p:spPr>
-        <p:txBody>
-          <a:bodyPr wrap="square" rtlCol="0" anchor="ctr"/>
-          <a:lstStyle/>
-          <a:p>
-            <a:pPr indent="0" marL="0">
-              <a:buNone/>
-            </a:pPr>
-            <a:r>
-              <a:rPr lang="en-US" sz="1200" spc="300" kern="0" dirty="0">
-                <a:solidFill>
-                  <a:srgbClr val="C7A46A"/>
-                </a:solidFill>
-                <a:latin typeface="Calibri" pitchFamily="34" charset="0"/>
-                <a:ea typeface="Calibri" pitchFamily="34" charset="-122"/>
-                <a:cs typeface="Calibri" pitchFamily="34" charset="-120"/>
-              </a:rPr>
-              <a:t>CONTACT</a:t>
-            </a:r>
-            <a:endParaRPr lang="en-US" sz="1200" dirty="0"/>
-          </a:p>
-        </p:txBody>
-      </p:sp>
-      <p:sp>
-        <p:nvSpPr>
-          <p:cNvPr id="4" name="Text 2"/>
-          <p:cNvSpPr/>
-          <p:nvPr/>
-        </p:nvSpPr>
-        <p:spPr>
-          <a:xfrm>
-            <a:off x="777240" y="1417320"/>
-            <a:ext cx="9144000" cy="914400"/>
-          </a:xfrm>
-          <a:prstGeom prst="rect">
-            <a:avLst/>
-          </a:prstGeom>
-          <a:noFill/>
-          <a:ln/>
-        </p:spPr>
-        <p:txBody>
-          <a:bodyPr wrap="square" lIns="0" tIns="0" rIns="0" bIns="0" rtlCol="0" anchor="ctr"/>
-          <a:lstStyle/>
-          <a:p>
-            <a:pPr indent="0" marL="0">
-              <a:buNone/>
-            </a:pPr>
-            <a:r>
-              <a:rPr lang="en-US" sz="4000" dirty="0">
-                <a:solidFill>
-                  <a:srgbClr val="FBF7EF"/>
-                </a:solidFill>
-                <a:latin typeface="Cambria" pitchFamily="34" charset="0"/>
-                <a:ea typeface="Cambria" pitchFamily="34" charset="-122"/>
-                <a:cs typeface="Cambria" pitchFamily="34" charset="-120"/>
-              </a:rPr>
-              <a:t>Vencore Design Co.</a:t>
-            </a:r>
-            <a:endParaRPr lang="en-US" sz="4000" dirty="0"/>
-          </a:p>
-        </p:txBody>
-      </p:sp>
-      <p:sp>
-        <p:nvSpPr>
-          <p:cNvPr id="5" name="Shape 3"/>
-          <p:cNvSpPr/>
-          <p:nvPr/>
-        </p:nvSpPr>
-        <p:spPr>
-          <a:xfrm>
-            <a:off x="822960" y="2395728"/>
-            <a:ext cx="822960" cy="0"/>
-          </a:xfrm>
-          <a:prstGeom prst="line">
-            <a:avLst/>
-          </a:prstGeom>
-          <a:noFill/>
-          <a:ln w="15875">
-            <a:solidFill>
-              <a:srgbClr val="9B6B3D"/>
-            </a:solidFill>
-            <a:prstDash val="solid"/>
-          </a:ln>
-        </p:spPr>
-      </p:sp>
-      <p:sp>
-        <p:nvSpPr>
-          <p:cNvPr id="6" name="Text 4"/>
-          <p:cNvSpPr/>
-          <p:nvPr/>
-        </p:nvSpPr>
-        <p:spPr>
-          <a:xfrm>
-            <a:off x="822960" y="2743200"/>
-            <a:ext cx="1828800" cy="365760"/>
-          </a:xfrm>
-          <a:prstGeom prst="rect">
-            <a:avLst/>
-          </a:prstGeom>
-          <a:noFill/>
-          <a:ln/>
-        </p:spPr>
-        <p:txBody>
-          <a:bodyPr wrap="square" rtlCol="0" anchor="ctr"/>
-          <a:lstStyle/>
-          <a:p>
-            <a:pPr indent="0" marL="0">
-              <a:buNone/>
-            </a:pPr>
-            <a:r>
-              <a:rPr lang="en-US" sz="950" spc="150" kern="0" dirty="0">
-                <a:solidFill>
-                  <a:srgbClr val="9A9086"/>
-                </a:solidFill>
-                <a:latin typeface="Calibri" pitchFamily="34" charset="0"/>
-                <a:ea typeface="Calibri" pitchFamily="34" charset="-122"/>
-                <a:cs typeface="Calibri" pitchFamily="34" charset="-120"/>
-              </a:rPr>
-              <a:t>WEBSITE</a:t>
-            </a:r>
-            <a:endParaRPr lang="en-US" sz="950" dirty="0"/>
-          </a:p>
-        </p:txBody>
-      </p:sp>
-      <p:sp>
-        <p:nvSpPr>
-          <p:cNvPr id="7" name="Text 5"/>
-          <p:cNvSpPr/>
-          <p:nvPr/>
-        </p:nvSpPr>
-        <p:spPr>
-          <a:xfrm>
-            <a:off x="2743200" y="2743200"/>
-            <a:ext cx="5943600" cy="365760"/>
-          </a:xfrm>
-          <a:prstGeom prst="rect">
-            <a:avLst/>
-          </a:prstGeom>
-          <a:noFill/>
-          <a:ln/>
-        </p:spPr>
-        <p:txBody>
-          <a:bodyPr wrap="square" rtlCol="0" anchor="ctr"/>
-          <a:lstStyle/>
-          <a:p>
-            <a:pPr indent="0" marL="0">
-              <a:buNone/>
-            </a:pPr>
-            <a:r>
-              <a:rPr lang="en-US" sz="1350" dirty="0">
-                <a:solidFill>
-                  <a:srgbClr val="FBF7EF"/>
-                </a:solidFill>
-                <a:latin typeface="Calibri" pitchFamily="34" charset="0"/>
-                <a:ea typeface="Calibri" pitchFamily="34" charset="-122"/>
-                <a:cs typeface="Calibri" pitchFamily="34" charset="-120"/>
-              </a:rPr>
-              <a:t>vencoredesign.com</a:t>
-            </a:r>
-            <a:endParaRPr lang="en-US" sz="1350" dirty="0"/>
-          </a:p>
-        </p:txBody>
-      </p:sp>
-      <p:sp>
-        <p:nvSpPr>
-          <p:cNvPr id="8" name="Text 6"/>
-          <p:cNvSpPr/>
-          <p:nvPr/>
-        </p:nvSpPr>
-        <p:spPr>
-          <a:xfrm>
-            <a:off x="822960" y="3200400"/>
-            <a:ext cx="1828800" cy="365760"/>
-          </a:xfrm>
-          <a:prstGeom prst="rect">
-            <a:avLst/>
-          </a:prstGeom>
-          <a:noFill/>
-          <a:ln/>
-        </p:spPr>
-        <p:txBody>
-          <a:bodyPr wrap="square" rtlCol="0" anchor="ctr"/>
-          <a:lstStyle/>
-          <a:p>
-            <a:pPr indent="0" marL="0">
-              <a:buNone/>
-            </a:pPr>
-            <a:r>
-              <a:rPr lang="en-US" sz="950" spc="150" kern="0" dirty="0">
-                <a:solidFill>
-                  <a:srgbClr val="9A9086"/>
-                </a:solidFill>
-                <a:latin typeface="Calibri" pitchFamily="34" charset="0"/>
-                <a:ea typeface="Calibri" pitchFamily="34" charset="-122"/>
-                <a:cs typeface="Calibri" pitchFamily="34" charset="-120"/>
-              </a:rPr>
-              <a:t>EMAIL</a:t>
-            </a:r>
-            <a:endParaRPr lang="en-US" sz="950" dirty="0"/>
-          </a:p>
-        </p:txBody>
-      </p:sp>
-      <p:sp>
-        <p:nvSpPr>
-          <p:cNvPr id="9" name="Text 7"/>
-          <p:cNvSpPr/>
-          <p:nvPr/>
-        </p:nvSpPr>
-        <p:spPr>
-          <a:xfrm>
-            <a:off x="2743200" y="3200400"/>
-            <a:ext cx="5943600" cy="365760"/>
-          </a:xfrm>
-          <a:prstGeom prst="rect">
-            <a:avLst/>
-          </a:prstGeom>
-          <a:noFill/>
-          <a:ln/>
-        </p:spPr>
-        <p:txBody>
-          <a:bodyPr wrap="square" rtlCol="0" anchor="ctr"/>
-          <a:lstStyle/>
-          <a:p>
-            <a:pPr indent="0" marL="0">
-              <a:buNone/>
-            </a:pPr>
-            <a:r>
-              <a:rPr lang="en-US" sz="1350" dirty="0">
-                <a:solidFill>
-                  <a:srgbClr val="FBF7EF"/>
-                </a:solidFill>
-                <a:latin typeface="Calibri" pitchFamily="34" charset="0"/>
-                <a:ea typeface="Calibri" pitchFamily="34" charset="-122"/>
-                <a:cs typeface="Calibri" pitchFamily="34" charset="-120"/>
-              </a:rPr>
-              <a:t>info@vencoredesign.com</a:t>
-            </a:r>
-            <a:endParaRPr lang="en-US" sz="1350" dirty="0"/>
-          </a:p>
-        </p:txBody>
-      </p:sp>
-      <p:sp>
-        <p:nvSpPr>
-          <p:cNvPr id="10" name="Text 8"/>
-          <p:cNvSpPr/>
-          <p:nvPr/>
-        </p:nvSpPr>
-        <p:spPr>
-          <a:xfrm>
-            <a:off x="822960" y="3657600"/>
-            <a:ext cx="1828800" cy="365760"/>
-          </a:xfrm>
-          <a:prstGeom prst="rect">
-            <a:avLst/>
-          </a:prstGeom>
-          <a:noFill/>
-          <a:ln/>
-        </p:spPr>
-        <p:txBody>
-          <a:bodyPr wrap="square" rtlCol="0" anchor="ctr"/>
-          <a:lstStyle/>
-          <a:p>
-            <a:pPr indent="0" marL="0">
-              <a:buNone/>
-            </a:pPr>
-            <a:r>
-              <a:rPr lang="en-US" sz="950" spc="150" kern="0" dirty="0">
-                <a:solidFill>
-                  <a:srgbClr val="9A9086"/>
-                </a:solidFill>
-                <a:latin typeface="Calibri" pitchFamily="34" charset="0"/>
-                <a:ea typeface="Calibri" pitchFamily="34" charset="-122"/>
-                <a:cs typeface="Calibri" pitchFamily="34" charset="-120"/>
-              </a:rPr>
-              <a:t>WHATSAPP</a:t>
-            </a:r>
-            <a:endParaRPr lang="en-US" sz="950" dirty="0"/>
-          </a:p>
-        </p:txBody>
-      </p:sp>
-      <p:sp>
-        <p:nvSpPr>
-          <p:cNvPr id="11" name="Text 9"/>
-          <p:cNvSpPr/>
-          <p:nvPr/>
-        </p:nvSpPr>
-        <p:spPr>
-          <a:xfrm>
-            <a:off x="2743200" y="3657600"/>
-            <a:ext cx="5943600" cy="365760"/>
-          </a:xfrm>
-          <a:prstGeom prst="rect">
-            <a:avLst/>
-          </a:prstGeom>
-          <a:noFill/>
-          <a:ln/>
-        </p:spPr>
-        <p:txBody>
-          <a:bodyPr wrap="square" rtlCol="0" anchor="ctr"/>
-          <a:lstStyle/>
-          <a:p>
-            <a:pPr indent="0" marL="0">
-              <a:buNone/>
-            </a:pPr>
-            <a:r>
-              <a:rPr lang="en-US" sz="1350" dirty="0">
-                <a:solidFill>
-                  <a:srgbClr val="FBF7EF"/>
-                </a:solidFill>
-                <a:latin typeface="Calibri" pitchFamily="34" charset="0"/>
-                <a:ea typeface="Calibri" pitchFamily="34" charset="-122"/>
-                <a:cs typeface="Calibri" pitchFamily="34" charset="-120"/>
-              </a:rPr>
-              <a:t>+91 70931 27880</a:t>
-            </a:r>
-            <a:endParaRPr lang="en-US" sz="1350" dirty="0"/>
-          </a:p>
-        </p:txBody>
-      </p:sp>
-      <p:sp>
-        <p:nvSpPr>
-          <p:cNvPr id="12" name="Text 10"/>
-          <p:cNvSpPr/>
-          <p:nvPr/>
-        </p:nvSpPr>
-        <p:spPr>
-          <a:xfrm>
-            <a:off x="822960" y="4114800"/>
-            <a:ext cx="1828800" cy="365760"/>
-          </a:xfrm>
-          <a:prstGeom prst="rect">
-            <a:avLst/>
-          </a:prstGeom>
-          <a:noFill/>
-          <a:ln/>
-        </p:spPr>
-        <p:txBody>
-          <a:bodyPr wrap="square" rtlCol="0" anchor="ctr"/>
-          <a:lstStyle/>
-          <a:p>
-            <a:pPr indent="0" marL="0">
-              <a:buNone/>
-            </a:pPr>
-            <a:r>
-              <a:rPr lang="en-US" sz="950" spc="150" kern="0" dirty="0">
-                <a:solidFill>
-                  <a:srgbClr val="9A9086"/>
-                </a:solidFill>
-                <a:latin typeface="Calibri" pitchFamily="34" charset="0"/>
-                <a:ea typeface="Calibri" pitchFamily="34" charset="-122"/>
-                <a:cs typeface="Calibri" pitchFamily="34" charset="-120"/>
-              </a:rPr>
-              <a:t>PHONE</a:t>
-            </a:r>
-            <a:endParaRPr lang="en-US" sz="950" dirty="0"/>
-          </a:p>
-        </p:txBody>
-      </p:sp>
-      <p:sp>
-        <p:nvSpPr>
-          <p:cNvPr id="13" name="Text 11"/>
-          <p:cNvSpPr/>
-          <p:nvPr/>
-        </p:nvSpPr>
-        <p:spPr>
-          <a:xfrm>
-            <a:off x="2743200" y="4114800"/>
-            <a:ext cx="5943600" cy="365760"/>
-          </a:xfrm>
-          <a:prstGeom prst="rect">
-            <a:avLst/>
-          </a:prstGeom>
-          <a:noFill/>
-          <a:ln/>
-        </p:spPr>
-        <p:txBody>
-          <a:bodyPr wrap="square" rtlCol="0" anchor="ctr"/>
-          <a:lstStyle/>
-          <a:p>
-            <a:pPr indent="0" marL="0">
-              <a:buNone/>
-            </a:pPr>
-            <a:r>
-              <a:rPr lang="en-US" sz="1350" dirty="0">
-                <a:solidFill>
-                  <a:srgbClr val="FBF7EF"/>
-                </a:solidFill>
-                <a:latin typeface="Calibri" pitchFamily="34" charset="0"/>
-                <a:ea typeface="Calibri" pitchFamily="34" charset="-122"/>
-                <a:cs typeface="Calibri" pitchFamily="34" charset="-120"/>
-              </a:rPr>
-              <a:t>+91 98660 14664</a:t>
-            </a:r>
-            <a:endParaRPr lang="en-US" sz="1350" dirty="0"/>
-          </a:p>
-        </p:txBody>
-      </p:sp>
-      <p:sp>
-        <p:nvSpPr>
-          <p:cNvPr id="16" name="Shape 14"/>
-          <p:cNvSpPr/>
-          <p:nvPr/>
-        </p:nvSpPr>
-        <p:spPr>
-          <a:xfrm>
-            <a:off x="822960" y="5166360"/>
-            <a:ext cx="7863840" cy="0"/>
-          </a:xfrm>
-          <a:prstGeom prst="line">
-            <a:avLst/>
-          </a:prstGeom>
-          <a:noFill/>
-          <a:ln w="12700">
-            <a:solidFill>
-              <a:srgbClr val="2A2219"/>
-            </a:solidFill>
-            <a:prstDash val="solid"/>
-          </a:ln>
-        </p:spPr>
-      </p:sp>
-      <p:sp>
-        <p:nvSpPr>
-          <p:cNvPr id="17" name="Text 15"/>
-          <p:cNvSpPr/>
-          <p:nvPr/>
-        </p:nvSpPr>
-        <p:spPr>
-          <a:xfrm>
-            <a:off x="822960" y="5349240"/>
-            <a:ext cx="1828800" cy="274320"/>
-          </a:xfrm>
-          <a:prstGeom prst="rect">
-            <a:avLst/>
-          </a:prstGeom>
-          <a:noFill/>
-          <a:ln/>
-        </p:spPr>
-        <p:txBody>
-          <a:bodyPr wrap="square" rtlCol="0" anchor="ctr"/>
-          <a:lstStyle/>
-          <a:p>
-            <a:pPr indent="0" marL="0">
-              <a:buNone/>
-            </a:pPr>
-            <a:r>
-              <a:rPr lang="en-US" sz="950" spc="150" kern="0" dirty="0">
-                <a:solidFill>
-                  <a:srgbClr val="9A9086"/>
-                </a:solidFill>
-                <a:latin typeface="Calibri" pitchFamily="34" charset="0"/>
-                <a:ea typeface="Calibri" pitchFamily="34" charset="-122"/>
-                <a:cs typeface="Calibri" pitchFamily="34" charset="-120"/>
-              </a:rPr>
-              <a:t>STUDIO</a:t>
-            </a:r>
-            <a:endParaRPr lang="en-US" sz="950" dirty="0"/>
-          </a:p>
-        </p:txBody>
-      </p:sp>
-      <p:sp>
-        <p:nvSpPr>
-          <p:cNvPr id="18" name="Text 16"/>
-          <p:cNvSpPr/>
-          <p:nvPr/>
-        </p:nvSpPr>
-        <p:spPr>
-          <a:xfrm>
-            <a:off x="2743200" y="5349240"/>
-            <a:ext cx="6400800" cy="548640"/>
-          </a:xfrm>
-          <a:prstGeom prst="rect">
-            <a:avLst/>
-          </a:prstGeom>
-          <a:noFill/>
-          <a:ln/>
-        </p:spPr>
-        <p:txBody>
-          <a:bodyPr wrap="square" rtlCol="0" anchor="ctr"/>
-          <a:lstStyle/>
-          <a:p>
-            <a:pPr indent="0" marL="0">
-              <a:lnSpc>
-                <a:spcPct val="125000"/>
-              </a:lnSpc>
-              <a:buNone/>
-            </a:pPr>
-            <a:r>
-              <a:rPr lang="en-US" sz="1200" dirty="0">
-                <a:solidFill>
-                  <a:srgbClr val="FBF7EF"/>
-                </a:solidFill>
-                <a:latin typeface="Calibri" pitchFamily="34" charset="0"/>
-                <a:ea typeface="Calibri" pitchFamily="34" charset="-122"/>
-                <a:cs typeface="Calibri" pitchFamily="34" charset="-120"/>
-              </a:rPr>
-              <a:t>Door No. 9-24/9B/2, 9th Floor, Vaishnavi Cymbol,</a:t>
-            </a:r>
-            <a:endParaRPr lang="en-US" sz="1200" dirty="0"/>
-          </a:p>
-          <a:p>
-            <a:pPr indent="0" marL="0">
-              <a:lnSpc>
-                <a:spcPct val="125000"/>
-              </a:lnSpc>
-              <a:buNone/>
-            </a:pPr>
-            <a:r>
-              <a:rPr lang="en-US" sz="1200" dirty="0">
-                <a:solidFill>
-                  <a:srgbClr val="FBF7EF"/>
-                </a:solidFill>
-                <a:latin typeface="Calibri" pitchFamily="34" charset="0"/>
-                <a:ea typeface="Calibri" pitchFamily="34" charset="-122"/>
-                <a:cs typeface="Calibri" pitchFamily="34" charset="-120"/>
-              </a:rPr>
-              <a:t>Financial District, Nanakramguda, Hyderabad — 500032</a:t>
-            </a:r>
-            <a:endParaRPr lang="en-US" sz="1200" dirty="0"/>
-          </a:p>
-        </p:txBody>
-      </p:sp>
-    </p:spTree>
-  </p:cSld>
-  <p:clrMapOvr>
-    <a:masterClrMapping/>
-  </p:clrMapOvr>
-</p:sld>
+<ns0:sld xmlns:ns0="http://schemas.openxmlformats.org/presentationml/2006/main" xmlns:ns1="http://schemas.openxmlformats.org/drawingml/2006/main">
+  <ns0:cSld name="Slide 11">
+    <ns0:bg>
+      <ns0:bgPr>
+        <ns1:solidFill>
+          <ns1:srgbClr val="221C17"/>
+        </ns1:solidFill>
+      </ns0:bgPr>
+    </ns0:bg>
+    <ns0:spTree>
+      <ns0:nvGrpSpPr>
+        <ns0:cNvPr id="1" name=""/>
+        <ns0:cNvGrpSpPr/>
+        <ns0:nvPr/>
+      </ns0:nvGrpSpPr>
+      <ns0:grpSpPr>
+        <ns1:xfrm>
+          <ns1:off x="0" y="0"/>
+          <ns1:ext cx="0" cy="0"/>
+          <ns1:chOff x="0" y="0"/>
+          <ns1:chExt cx="0" cy="0"/>
+        </ns1:xfrm>
+      </ns0:grpSpPr>
+      <ns0:sp>
+        <ns0:nvSpPr>
+          <ns0:cNvPr id="2" name="Shape 0"/>
+          <ns0:cNvSpPr/>
+          <ns0:nvPr/>
+        </ns0:nvSpPr>
+        <ns0:spPr>
+          <ns1:xfrm>
+            <ns1:off x="8686800" y="-2286000"/>
+            <ns1:ext cx="5486400" cy="5486400"/>
+          </ns1:xfrm>
+          <ns1:prstGeom prst="ellipse">
+            <ns1:avLst/>
+          </ns1:prstGeom>
+          <ns1:solidFill>
+            <ns1:srgbClr val="2A2219">
+              <ns1:alpha val="65000"/>
+            </ns1:srgbClr>
+          </ns1:solidFill>
+          <ns1:ln/>
+        </ns0:spPr>
+      </ns0:sp>
+      <ns0:sp>
+        <ns0:nvSpPr>
+          <ns0:cNvPr id="3" name="Text 1"/>
+          <ns0:cNvSpPr/>
+          <ns0:nvPr/>
+        </ns0:nvSpPr>
+        <ns0:spPr>
+          <ns1:xfrm>
+            <ns1:off x="822960" y="1051560"/>
+            <ns1:ext cx="7315200" cy="365760"/>
+          </ns1:xfrm>
+          <ns1:prstGeom prst="rect">
+            <ns1:avLst/>
+          </ns1:prstGeom>
+          <ns1:noFill/>
+          <ns1:ln/>
+        </ns0:spPr>
+        <ns0:txBody>
+          <ns1:bodyPr wrap="square" rtlCol="0" anchor="ctr"/>
+          <ns1:lstStyle/>
+          <ns1:p>
+            <ns1:pPr indent="0" marL="0">
+              <ns1:buNone/>
+            </ns1:pPr>
+            <ns1:r>
+              <ns1:rPr lang="en-US" sz="1200" spc="300" kern="0" dirty="0">
+                <ns1:solidFill>
+                  <ns1:srgbClr val="C7A46A"/>
+                </ns1:solidFill>
+                <ns1:latin typeface="Calibri" pitchFamily="34" charset="0"/>
+                <ns1:ea typeface="Calibri" pitchFamily="34" charset="-122"/>
+                <ns1:cs typeface="Calibri" pitchFamily="34" charset="-120"/>
+              </ns1:rPr>
+              <ns1:t>CONTACT</ns1:t>
+            </ns1:r>
+            <ns1:endParaRPr lang="en-US" sz="1200" dirty="0"/>
+          </ns1:p>
+        </ns0:txBody>
+      </ns0:sp>
+      <ns0:sp>
+        <ns0:nvSpPr>
+          <ns0:cNvPr id="4" name="Text 2"/>
+          <ns0:cNvSpPr/>
+          <ns0:nvPr/>
+        </ns0:nvSpPr>
+        <ns0:spPr>
+          <ns1:xfrm>
+            <ns1:off x="777240" y="1417320"/>
+            <ns1:ext cx="9144000" cy="914400"/>
+          </ns1:xfrm>
+          <ns1:prstGeom prst="rect">
+            <ns1:avLst/>
+          </ns1:prstGeom>
+          <ns1:noFill/>
+          <ns1:ln/>
+        </ns0:spPr>
+        <ns0:txBody>
+          <ns1:bodyPr wrap="square" lIns="0" tIns="0" rIns="0" bIns="0" rtlCol="0" anchor="ctr"/>
+          <ns1:lstStyle/>
+          <ns1:p>
+            <ns1:pPr indent="0" marL="0">
+              <ns1:buNone/>
+            </ns1:pPr>
+            <ns1:r>
+              <ns1:rPr lang="en-US" sz="4000" dirty="0">
+                <ns1:solidFill>
+                  <ns1:srgbClr val="FBF7EF"/>
+                </ns1:solidFill>
+                <ns1:latin typeface="Cambria" pitchFamily="34" charset="0"/>
+                <ns1:ea typeface="Cambria" pitchFamily="34" charset="-122"/>
+                <ns1:cs typeface="Cambria" pitchFamily="34" charset="-120"/>
+              </ns1:rPr>
+              <ns1:t>Vencore Design Co.</ns1:t>
+            </ns1:r>
+            <ns1:endParaRPr lang="en-US" sz="4000" dirty="0"/>
+          </ns1:p>
+        </ns0:txBody>
+      </ns0:sp>
+      <ns0:sp>
+        <ns0:nvSpPr>
+          <ns0:cNvPr id="5" name="Shape 3"/>
+          <ns0:cNvSpPr/>
+          <ns0:nvPr/>
+        </ns0:nvSpPr>
+        <ns0:spPr>
+          <ns1:xfrm>
+            <ns1:off x="822960" y="2395728"/>
+            <ns1:ext cx="822960" cy="0"/>
+          </ns1:xfrm>
+          <ns1:prstGeom prst="line">
+            <ns1:avLst/>
+          </ns1:prstGeom>
+          <ns1:noFill/>
+          <ns1:ln w="15875">
+            <ns1:solidFill>
+              <ns1:srgbClr val="9B6B3D"/>
+            </ns1:solidFill>
+            <ns1:prstDash val="solid"/>
+          </ns1:ln>
+        </ns0:spPr>
+      </ns0:sp>
+      <ns0:sp>
+        <ns0:nvSpPr>
+          <ns0:cNvPr id="6" name="Text 4"/>
+          <ns0:cNvSpPr/>
+          <ns0:nvPr/>
+        </ns0:nvSpPr>
+        <ns0:spPr>
+          <ns1:xfrm>
+            <ns1:off x="822960" y="2743200"/>
+            <ns1:ext cx="1828800" cy="365760"/>
+          </ns1:xfrm>
+          <ns1:prstGeom prst="rect">
+            <ns1:avLst/>
+          </ns1:prstGeom>
+          <ns1:noFill/>
+          <ns1:ln/>
+        </ns0:spPr>
+        <ns0:txBody>
+          <ns1:bodyPr wrap="square" rtlCol="0" anchor="ctr"/>
+          <ns1:lstStyle/>
+          <ns1:p>
+            <ns1:pPr indent="0" marL="0">
+              <ns1:buNone/>
+            </ns1:pPr>
+            <ns1:r>
+              <ns1:rPr lang="en-US" sz="950" spc="150" kern="0" dirty="0">
+                <ns1:solidFill>
+                  <ns1:srgbClr val="9A9086"/>
+                </ns1:solidFill>
+                <ns1:latin typeface="Calibri" pitchFamily="34" charset="0"/>
+                <ns1:ea typeface="Calibri" pitchFamily="34" charset="-122"/>
+                <ns1:cs typeface="Calibri" pitchFamily="34" charset="-120"/>
+              </ns1:rPr>
+              <ns1:t>WEBSITE</ns1:t>
+            </ns1:r>
+            <ns1:endParaRPr lang="en-US" sz="950" dirty="0"/>
+          </ns1:p>
+        </ns0:txBody>
+      </ns0:sp>
+      <ns0:sp>
+        <ns0:nvSpPr>
+          <ns0:cNvPr id="7" name="Text 5"/>
+          <ns0:cNvSpPr/>
+          <ns0:nvPr/>
+        </ns0:nvSpPr>
+        <ns0:spPr>
+          <ns1:xfrm>
+            <ns1:off x="2743200" y="2743200"/>
+            <ns1:ext cx="5943600" cy="365760"/>
+          </ns1:xfrm>
+          <ns1:prstGeom prst="rect">
+            <ns1:avLst/>
+          </ns1:prstGeom>
+          <ns1:noFill/>
+          <ns1:ln/>
+        </ns0:spPr>
+        <ns0:txBody>
+          <ns1:bodyPr wrap="square" rtlCol="0" anchor="ctr"/>
+          <ns1:lstStyle/>
+          <ns1:p>
+            <ns1:pPr indent="0" marL="0">
+              <ns1:buNone/>
+            </ns1:pPr>
+            <ns1:r>
+              <ns1:rPr lang="en-US" sz="1350" dirty="0">
+                <ns1:solidFill>
+                  <ns1:srgbClr val="FBF7EF"/>
+                </ns1:solidFill>
+                <ns1:latin typeface="Calibri" pitchFamily="34" charset="0"/>
+                <ns1:ea typeface="Calibri" pitchFamily="34" charset="-122"/>
+                <ns1:cs typeface="Calibri" pitchFamily="34" charset="-120"/>
+              </ns1:rPr>
+              <ns1:t>vencoredesign.com</ns1:t>
+            </ns1:r>
+            <ns1:endParaRPr lang="en-US" sz="1350" dirty="0"/>
+          </ns1:p>
+        </ns0:txBody>
+      </ns0:sp>
+      <ns0:sp>
+        <ns0:nvSpPr>
+          <ns0:cNvPr id="8" name="Text 6"/>
+          <ns0:cNvSpPr/>
+          <ns0:nvPr/>
+        </ns0:nvSpPr>
+        <ns0:spPr>
+          <ns1:xfrm>
+            <ns1:off x="822960" y="3200400"/>
+            <ns1:ext cx="1828800" cy="365760"/>
+          </ns1:xfrm>
+          <ns1:prstGeom prst="rect">
+            <ns1:avLst/>
+          </ns1:prstGeom>
+          <ns1:noFill/>
+          <ns1:ln/>
+        </ns0:spPr>
+        <ns0:txBody>
+          <ns1:bodyPr wrap="square" rtlCol="0" anchor="ctr"/>
+          <ns1:lstStyle/>
+          <ns1:p>
+            <ns1:pPr indent="0" marL="0">
+              <ns1:buNone/>
+            </ns1:pPr>
+            <ns1:r>
+              <ns1:rPr lang="en-US" sz="950" spc="150" kern="0" dirty="0">
+                <ns1:solidFill>
+                  <ns1:srgbClr val="9A9086"/>
+                </ns1:solidFill>
+                <ns1:latin typeface="Calibri" pitchFamily="34" charset="0"/>
+                <ns1:ea typeface="Calibri" pitchFamily="34" charset="-122"/>
+                <ns1:cs typeface="Calibri" pitchFamily="34" charset="-120"/>
+              </ns1:rPr>
+              <ns1:t>EMAIL</ns1:t>
+            </ns1:r>
+            <ns1:endParaRPr lang="en-US" sz="950" dirty="0"/>
+          </ns1:p>
+        </ns0:txBody>
+      </ns0:sp>
+      <ns0:sp>
+        <ns0:nvSpPr>
+          <ns0:cNvPr id="9" name="Text 7"/>
+          <ns0:cNvSpPr/>
+          <ns0:nvPr/>
+        </ns0:nvSpPr>
+        <ns0:spPr>
+          <ns1:xfrm>
+            <ns1:off x="2743200" y="3200400"/>
+            <ns1:ext cx="5943600" cy="365760"/>
+          </ns1:xfrm>
+          <ns1:prstGeom prst="rect">
+            <ns1:avLst/>
+          </ns1:prstGeom>
+          <ns1:noFill/>
+          <ns1:ln/>
+        </ns0:spPr>
+        <ns0:txBody>
+          <ns1:bodyPr wrap="square" rtlCol="0" anchor="ctr"/>
+          <ns1:lstStyle/>
+          <ns1:p>
+            <ns1:pPr indent="0" marL="0">
+              <ns1:buNone/>
+            </ns1:pPr>
+            <ns1:r>
+              <ns1:rPr lang="en-US" sz="1350" dirty="0">
+                <ns1:solidFill>
+                  <ns1:srgbClr val="FBF7EF"/>
+                </ns1:solidFill>
+                <ns1:latin typeface="Calibri" pitchFamily="34" charset="0"/>
+                <ns1:ea typeface="Calibri" pitchFamily="34" charset="-122"/>
+                <ns1:cs typeface="Calibri" pitchFamily="34" charset="-120"/>
+              </ns1:rPr>
+              <ns1:t>info@vencoredesign.com</ns1:t>
+            </ns1:r>
+            <ns1:endParaRPr lang="en-US" sz="1350" dirty="0"/>
+          </ns1:p>
+        </ns0:txBody>
+      </ns0:sp>
+      <ns0:sp>
+        <ns0:nvSpPr>
+          <ns0:cNvPr id="10" name="Text 8"/>
+          <ns0:cNvSpPr/>
+          <ns0:nvPr/>
+        </ns0:nvSpPr>
+        <ns0:spPr>
+          <ns1:xfrm>
+            <ns1:off x="822960" y="3657600"/>
+            <ns1:ext cx="1828800" cy="365760"/>
+          </ns1:xfrm>
+          <ns1:prstGeom prst="rect">
+            <ns1:avLst/>
+          </ns1:prstGeom>
+          <ns1:noFill/>
+          <ns1:ln/>
+        </ns0:spPr>
+        <ns0:txBody>
+          <ns1:bodyPr wrap="square" rtlCol="0" anchor="ctr"/>
+          <ns1:lstStyle/>
+          <ns1:p>
+            <ns1:pPr indent="0" marL="0">
+              <ns1:buNone/>
+            </ns1:pPr>
+            <ns1:r>
+              <ns1:rPr lang="en-US" sz="950" spc="150" kern="0" dirty="0">
+                <ns1:solidFill>
+                  <ns1:srgbClr val="9A9086"/>
+                </ns1:solidFill>
+                <ns1:latin typeface="Calibri" pitchFamily="34" charset="0"/>
+                <ns1:ea typeface="Calibri" pitchFamily="34" charset="-122"/>
+                <ns1:cs typeface="Calibri" pitchFamily="34" charset="-120"/>
+              </ns1:rPr>
+              <ns1:t>WHATSAPP</ns1:t>
+            </ns1:r>
+            <ns1:endParaRPr lang="en-US" sz="950" dirty="0"/>
+          </ns1:p>
+        </ns0:txBody>
+      </ns0:sp>
+      <ns0:sp>
+        <ns0:nvSpPr>
+          <ns0:cNvPr id="11" name="Text 9"/>
+          <ns0:cNvSpPr/>
+          <ns0:nvPr/>
+        </ns0:nvSpPr>
+        <ns0:spPr>
+          <ns1:xfrm>
+            <ns1:off x="2743200" y="3657600"/>
+            <ns1:ext cx="5943600" cy="365760"/>
+          </ns1:xfrm>
+          <ns1:prstGeom prst="rect">
+            <ns1:avLst/>
+          </ns1:prstGeom>
+          <ns1:noFill/>
+          <ns1:ln/>
+        </ns0:spPr>
+        <ns0:txBody>
+          <ns1:bodyPr wrap="square" rtlCol="0" anchor="ctr"/>
+          <ns1:lstStyle/>
+          <ns1:p>
+            <ns1:pPr indent="0" marL="0">
+              <ns1:buNone/>
+            </ns1:pPr>
+            <ns1:r>
+              <ns1:rPr lang="en-US" sz="1350" dirty="0">
+                <ns1:solidFill>
+                  <ns1:srgbClr val="FBF7EF"/>
+                </ns1:solidFill>
+                <ns1:latin typeface="Calibri" pitchFamily="34" charset="0"/>
+                <ns1:ea typeface="Calibri" pitchFamily="34" charset="-122"/>
+                <ns1:cs typeface="Calibri" pitchFamily="34" charset="-120"/>
+              </ns1:rPr>
+              <ns1:t>+91 70931 27880</ns1:t>
+            </ns1:r>
+            <ns1:endParaRPr lang="en-US" sz="1350" dirty="0"/>
+          </ns1:p>
+        </ns0:txBody>
+      </ns0:sp>
+      <ns0:sp>
+        <ns0:nvSpPr>
+          <ns0:cNvPr id="12" name="Text 10"/>
+          <ns0:cNvSpPr/>
+          <ns0:nvPr/>
+        </ns0:nvSpPr>
+        <ns0:spPr>
+          <ns1:xfrm>
+            <ns1:off x="822960" y="4114800"/>
+            <ns1:ext cx="1828800" cy="365760"/>
+          </ns1:xfrm>
+          <ns1:prstGeom prst="rect">
+            <ns1:avLst/>
+          </ns1:prstGeom>
+          <ns1:noFill/>
+          <ns1:ln/>
+        </ns0:spPr>
+        <ns0:txBody>
+          <ns1:bodyPr wrap="square" rtlCol="0" anchor="ctr"/>
+          <ns1:lstStyle/>
+          <ns1:p>
+            <ns1:pPr indent="0" marL="0">
+              <ns1:buNone/>
+            </ns1:pPr>
+            <ns1:r>
+              <ns1:rPr lang="en-US" sz="950" spc="150" kern="0" dirty="0">
+                <ns1:solidFill>
+                  <ns1:srgbClr val="9A9086"/>
+                </ns1:solidFill>
+                <ns1:latin typeface="Calibri" pitchFamily="34" charset="0"/>
+                <ns1:ea typeface="Calibri" pitchFamily="34" charset="-122"/>
+                <ns1:cs typeface="Calibri" pitchFamily="34" charset="-120"/>
+              </ns1:rPr>
+              <ns1:t>PHONE</ns1:t>
+            </ns1:r>
+            <ns1:endParaRPr lang="en-US" sz="950" dirty="0"/>
+          </ns1:p>
+        </ns0:txBody>
+      </ns0:sp>
+      <ns0:sp>
+        <ns0:nvSpPr>
+          <ns0:cNvPr id="13" name="Text 11"/>
+          <ns0:cNvSpPr/>
+          <ns0:nvPr/>
+        </ns0:nvSpPr>
+        <ns0:spPr>
+          <ns1:xfrm>
+            <ns1:off x="2743200" y="4114800"/>
+            <ns1:ext cx="5943600" cy="365760"/>
+          </ns1:xfrm>
+          <ns1:prstGeom prst="rect">
+            <ns1:avLst/>
+          </ns1:prstGeom>
+          <ns1:noFill/>
+          <ns1:ln/>
+        </ns0:spPr>
+        <ns0:txBody>
+          <ns1:bodyPr wrap="square" rtlCol="0" anchor="ctr"/>
+          <ns1:lstStyle/>
+          <ns1:p>
+            <ns1:pPr indent="0" marL="0">
+              <ns1:buNone/>
+            </ns1:pPr>
+            <ns1:r>
+              <ns1:rPr lang="en-US" sz="1350" dirty="0">
+                <ns1:solidFill>
+                  <ns1:srgbClr val="FBF7EF"/>
+                </ns1:solidFill>
+                <ns1:latin typeface="Calibri" pitchFamily="34" charset="0"/>
+                <ns1:ea typeface="Calibri" pitchFamily="34" charset="-122"/>
+                <ns1:cs typeface="Calibri" pitchFamily="34" charset="-120"/>
+              </ns1:rPr>
+              <ns1:t>+91 98660 14664</ns1:t>
+            </ns1:r>
+            <ns1:endParaRPr lang="en-US" sz="1350" dirty="0"/>
+          </ns1:p>
+        </ns0:txBody>
+      </ns0:sp>
+      <ns0:sp>
+        <ns0:nvSpPr>
+          <ns0:cNvPr id="16" name="Shape 14"/>
+          <ns0:cNvSpPr/>
+          <ns0:nvPr/>
+        </ns0:nvSpPr>
+        <ns0:spPr>
+          <ns1:xfrm>
+            <ns1:off x="822960" y="5166360"/>
+            <ns1:ext cx="7863840" cy="0"/>
+          </ns1:xfrm>
+          <ns1:prstGeom prst="line">
+            <ns1:avLst/>
+          </ns1:prstGeom>
+          <ns1:noFill/>
+          <ns1:ln w="12700">
+            <ns1:solidFill>
+              <ns1:srgbClr val="2A2219"/>
+            </ns1:solidFill>
+            <ns1:prstDash val="solid"/>
+          </ns1:ln>
+        </ns0:spPr>
+      </ns0:sp>
+      <ns0:sp>
+        <ns0:nvSpPr>
+          <ns0:cNvPr id="17" name="Text 15"/>
+          <ns0:cNvSpPr/>
+          <ns0:nvPr/>
+        </ns0:nvSpPr>
+        <ns0:spPr>
+          <ns1:xfrm>
+            <ns1:off x="822960" y="5349240"/>
+            <ns1:ext cx="1828800" cy="274320"/>
+          </ns1:xfrm>
+          <ns1:prstGeom prst="rect">
+            <ns1:avLst/>
+          </ns1:prstGeom>
+          <ns1:noFill/>
+          <ns1:ln/>
+        </ns0:spPr>
+        <ns0:txBody>
+          <ns1:bodyPr wrap="square" rtlCol="0" anchor="ctr"/>
+          <ns1:lstStyle/>
+          <ns1:p>
+            <ns1:pPr indent="0" marL="0">
+              <ns1:buNone/>
+            </ns1:pPr>
+            <ns1:r>
+              <ns1:rPr lang="en-US" sz="950" spc="150" kern="0" dirty="0">
+                <ns1:solidFill>
+                  <ns1:srgbClr val="9A9086"/>
+                </ns1:solidFill>
+                <ns1:latin typeface="Calibri" pitchFamily="34" charset="0"/>
+                <ns1:ea typeface="Calibri" pitchFamily="34" charset="-122"/>
+                <ns1:cs typeface="Calibri" pitchFamily="34" charset="-120"/>
+              </ns1:rPr>
+              <ns1:t>STUDIO</ns1:t>
+            </ns1:r>
+            <ns1:endParaRPr lang="en-US" sz="950" dirty="0"/>
+          </ns1:p>
+        </ns0:txBody>
+      </ns0:sp>
+      <ns0:sp>
+        <ns0:nvSpPr>
+          <ns0:cNvPr id="18" name="Text 16"/>
+          <ns0:cNvSpPr/>
+          <ns0:nvPr/>
+        </ns0:nvSpPr>
+        <ns0:spPr>
+          <ns1:xfrm>
+            <ns1:off x="2743200" y="5349240"/>
+            <ns1:ext cx="6400800" cy="548640"/>
+          </ns1:xfrm>
+          <ns1:prstGeom prst="rect">
+            <ns1:avLst/>
+          </ns1:prstGeom>
+          <ns1:noFill/>
+          <ns1:ln/>
+        </ns0:spPr>
+        <ns0:txBody>
+          <ns1:bodyPr wrap="square" rtlCol="0" anchor="ctr"/>
+          <ns1:lstStyle/>
+          <ns1:p>
+            <ns1:pPr indent="0" marL="0">
+              <ns1:lnSpc>
+                <ns1:spcPct val="125000"/>
+              </ns1:lnSpc>
+              <ns1:buNone/>
+            </ns1:pPr>
+            <ns1:r>
+              <ns1:rPr lang="en-US" sz="1200" dirty="0">
+                <ns1:solidFill>
+                  <ns1:srgbClr val="FBF7EF"/>
+                </ns1:solidFill>
+                <ns1:latin typeface="Calibri" pitchFamily="34" charset="0"/>
+                <ns1:ea typeface="Calibri" pitchFamily="34" charset="-122"/>
+                <ns1:cs typeface="Calibri" pitchFamily="34" charset="-120"/>
+              </ns1:rPr>
+              <ns1:t>Door No. 9-24/9B/2, 9th Floor, Vaishnavi Cymbol,</ns1:t>
+            </ns1:r>
+            <ns1:endParaRPr lang="en-US" sz="1200" dirty="0"/>
+          </ns1:p>
+          <ns1:p>
+            <ns1:pPr indent="0" marL="0">
+              <ns1:lnSpc>
+                <ns1:spcPct val="125000"/>
+              </ns1:lnSpc>
+              <ns1:buNone/>
+            </ns1:pPr>
+            <ns1:r>
+              <ns1:rPr lang="en-US" sz="1200" dirty="0">
+                <ns1:solidFill>
+                  <ns1:srgbClr val="FBF7EF"/>
+                </ns1:solidFill>
+                <ns1:latin typeface="Calibri" pitchFamily="34" charset="0"/>
+                <ns1:ea typeface="Calibri" pitchFamily="34" charset="-122"/>
+                <ns1:cs typeface="Calibri" pitchFamily="34" charset="-120"/>
+              </ns1:rPr>
+              <ns1:t>Financial District, Nanakramguda, Hyderabad — 500032</ns1:t>
+            </ns1:r>
+            <ns1:endParaRPr lang="en-US" sz="1200" dirty="0"/>
+          </ns1:p>
+        </ns0:txBody>
+      </ns0:sp>
+    </ns0:spTree>
+  </ns0:cSld>
+  <ns0:clrMapOvr>
+    <ns1:masterClrMapping/>
+  </ns0:clrMapOvr>
+</ns0:sld>
 </file>
 
 <file path=ppt/slides/slide2.xml><?xml version="1.0" encoding="utf-8"?>
@@ -4039,7 +4039,7 @@
                 <a:ea typeface="Cambria" pitchFamily="34" charset="-122"/>
                 <a:cs typeface="Cambria" pitchFamily="34" charset="-120"/>
               </a:rPr>
-              <a:t>Design. Build.</a:t>
+              <a:t>Design that</a:t>
             </a:r>
             <a:endParaRPr lang="en-US" sz="4600" dirty="0"/>
           </a:p>
@@ -4059,7 +4059,7 @@
                 <a:ea typeface="Cambria" pitchFamily="34" charset="-122"/>
                 <a:cs typeface="Cambria" pitchFamily="34" charset="-120"/>
               </a:rPr>
-              <a:t>Deliver.</a:t>
+              <a:t>delivers.</a:t>
             </a:r>
             <a:endParaRPr lang="en-US" sz="4600" dirty="0"/>
           </a:p>
@@ -4098,7 +4098,7 @@
                 <a:ea typeface="Cambria" pitchFamily="34" charset="-122"/>
                 <a:cs typeface="Cambria" pitchFamily="34" charset="-120"/>
               </a:rPr>
-              <a:t>One accountable partner from brief to handover.</a:t>
+              <a:t>Turnkey interiors, from brief to handover.</a:t>
             </a:r>
             <a:endParaRPr lang="en-US" sz="2000" dirty="0"/>
           </a:p>
@@ -4176,7 +4176,7 @@
                 <a:ea typeface="Cambria" pitchFamily="34" charset="-122"/>
                 <a:cs typeface="Cambria" pitchFamily="34" charset="-120"/>
               </a:rPr>
-              <a:t>Design</a:t>
+              <a:t>Concept</a:t>
             </a:r>
             <a:endParaRPr lang="en-US" sz="2200" dirty="0"/>
           </a:p>
@@ -4218,7 +4218,7 @@
                 <a:ea typeface="Calibri" pitchFamily="34" charset="-122"/>
                 <a:cs typeface="Calibri" pitchFamily="34" charset="-120"/>
               </a:rPr>
-              <a:t>Brief, brand, and built-space</a:t>
+              <a:t>Brief, brand, and building</a:t>
             </a:r>
             <a:endParaRPr lang="en-US" sz="1250" dirty="0"/>
           </a:p>
@@ -4238,7 +4238,7 @@
                 <a:ea typeface="Calibri" pitchFamily="34" charset="-122"/>
                 <a:cs typeface="Calibri" pitchFamily="34" charset="-120"/>
               </a:rPr>
-              <a:t>held in one vision.</a:t>
+              <a:t>held in one conversation.</a:t>
             </a:r>
             <a:endParaRPr lang="en-US" sz="1250" dirty="0"/>
           </a:p>
@@ -4316,7 +4316,7 @@
                 <a:ea typeface="Cambria" pitchFamily="34" charset="-122"/>
                 <a:cs typeface="Cambria" pitchFamily="34" charset="-120"/>
               </a:rPr>
-              <a:t>Build</a:t>
+              <a:t>Craft</a:t>
             </a:r>
             <a:endParaRPr lang="en-US" sz="2200" dirty="0"/>
           </a:p>
@@ -4358,7 +4358,7 @@
                 <a:ea typeface="Calibri" pitchFamily="34" charset="-122"/>
                 <a:cs typeface="Calibri" pitchFamily="34" charset="-120"/>
               </a:rPr>
-              <a:t>Execution, procurement, and</a:t>
+              <a:t>Material, light, and detail,</a:t>
             </a:r>
             <a:endParaRPr lang="en-US" sz="1250" dirty="0"/>
           </a:p>
@@ -4378,7 +4378,7 @@
                 <a:ea typeface="Calibri" pitchFamily="34" charset="-122"/>
                 <a:cs typeface="Calibri" pitchFamily="34" charset="-120"/>
               </a:rPr>
-              <a:t>installation under one roof.</a:t>
+              <a:t>resolved before site.</a:t>
             </a:r>
             <a:endParaRPr lang="en-US" sz="1250" dirty="0"/>
           </a:p>
@@ -4456,7 +4456,7 @@
                 <a:ea typeface="Cambria" pitchFamily="34" charset="-122"/>
                 <a:cs typeface="Cambria" pitchFamily="34" charset="-120"/>
               </a:rPr>
-              <a:t>Deliver</a:t>
+              <a:t>Delivery</a:t>
             </a:r>
             <a:endParaRPr lang="en-US" sz="2200" dirty="0"/>
           </a:p>
@@ -4498,7 +4498,7 @@
                 <a:ea typeface="Calibri" pitchFamily="34" charset="-122"/>
                 <a:cs typeface="Calibri" pitchFamily="34" charset="-120"/>
               </a:rPr>
-              <a:t>Turnkey handover, completed</a:t>
+              <a:t>Turnkey execution, handed</a:t>
             </a:r>
             <a:endParaRPr lang="en-US" sz="1250" dirty="0"/>
           </a:p>
@@ -4518,7 +4518,7 @@
                 <a:ea typeface="Calibri" pitchFamily="34" charset="-122"/>
                 <a:cs typeface="Calibri" pitchFamily="34" charset="-120"/>
               </a:rPr>
-              <a:t>once — done right.</a:t>
+              <a:t>over once — done right.</a:t>
             </a:r>
             <a:endParaRPr lang="en-US" sz="1250" dirty="0"/>
           </a:p>
@@ -6988,6 +6988,1206 @@
 </p:sld>
 </file>
 
+<file path=ppt/slides/slide5.xml><?xml version="1.0" encoding="utf-8"?>
+<p:sld xmlns:a="http://schemas.openxmlformats.org/drawingml/2006/main" xmlns:r="http://schemas.openxmlformats.org/officeDocument/2006/relationships" xmlns:p="http://schemas.openxmlformats.org/presentationml/2006/main">
+  <p:cSld name="Slide 5">
+    <p:bg>
+      <p:bgPr>
+        <a:solidFill>
+          <a:srgbClr val="FBF7EF"/>
+        </a:solidFill>
+      </p:bgPr>
+    </p:bg>
+    <p:spTree>
+      <p:nvGrpSpPr>
+        <p:cNvPr id="1" name=""/>
+        <p:cNvGrpSpPr/>
+        <p:nvPr/>
+      </p:nvGrpSpPr>
+      <p:grpSpPr>
+        <a:xfrm>
+          <a:off x="0" y="0"/>
+          <a:ext cx="0" cy="0"/>
+          <a:chOff x="0" y="0"/>
+          <a:chExt cx="0" cy="0"/>
+        </a:xfrm>
+      </p:grpSpPr>
+      <p:sp>
+        <p:nvSpPr>
+          <p:cNvPr id="2" name="Text 0"/>
+          <p:cNvSpPr/>
+          <p:nvPr/>
+        </p:nvSpPr>
+        <p:spPr>
+          <a:xfrm>
+            <a:off x="822960" y="502920"/>
+            <a:ext cx="7315200" cy="365760"/>
+          </a:xfrm>
+          <a:prstGeom prst="rect">
+            <a:avLst/>
+          </a:prstGeom>
+          <a:noFill/>
+          <a:ln/>
+        </p:spPr>
+        <p:txBody>
+          <a:bodyPr wrap="square" rtlCol="0" anchor="ctr"/>
+          <a:lstStyle/>
+          <a:p>
+            <a:pPr indent="0" marL="0">
+              <a:buNone/>
+            </a:pPr>
+            <a:r>
+              <a:rPr lang="en-US" sz="1200" spc="300" kern="0" dirty="0">
+                <a:solidFill>
+                  <a:srgbClr val="7A4728"/>
+                </a:solidFill>
+                <a:latin typeface="Calibri" pitchFamily="34" charset="0"/>
+                <a:ea typeface="Calibri" pitchFamily="34" charset="-122"/>
+                <a:cs typeface="Calibri" pitchFamily="34" charset="-120"/>
+              </a:rPr>
+              <a:t>COMPONENTS</a:t>
+            </a:r>
+            <a:endParaRPr lang="en-US" sz="1200" dirty="0"/>
+          </a:p>
+        </p:txBody>
+      </p:sp>
+      <p:sp>
+        <p:nvSpPr>
+          <p:cNvPr id="3" name="Text 1"/>
+          <p:cNvSpPr/>
+          <p:nvPr/>
+        </p:nvSpPr>
+        <p:spPr>
+          <a:xfrm>
+            <a:off x="777240" y="868680"/>
+            <a:ext cx="9601200" cy="822960"/>
+          </a:xfrm>
+          <a:prstGeom prst="rect">
+            <a:avLst/>
+          </a:prstGeom>
+          <a:noFill/>
+          <a:ln/>
+        </p:spPr>
+        <p:txBody>
+          <a:bodyPr wrap="square" lIns="0" tIns="0" rIns="0" bIns="0" rtlCol="0" anchor="ctr"/>
+          <a:lstStyle/>
+          <a:p>
+            <a:pPr indent="0" marL="0">
+              <a:buNone/>
+            </a:pPr>
+            <a:r>
+              <a:rPr lang="en-US" sz="3200" dirty="0">
+                <a:solidFill>
+                  <a:srgbClr val="2A2622"/>
+                </a:solidFill>
+                <a:latin typeface="Cambria" pitchFamily="34" charset="0"/>
+                <a:ea typeface="Cambria" pitchFamily="34" charset="-122"/>
+                <a:cs typeface="Cambria" pitchFamily="34" charset="-120"/>
+              </a:rPr>
+              <a:t>Interface, refined.</a:t>
+            </a:r>
+            <a:endParaRPr lang="en-US" sz="3200" dirty="0"/>
+          </a:p>
+        </p:txBody>
+      </p:sp>
+      <p:sp>
+        <p:nvSpPr>
+          <p:cNvPr id="4" name="Shape 2"/>
+          <p:cNvSpPr/>
+          <p:nvPr/>
+        </p:nvSpPr>
+        <p:spPr>
+          <a:xfrm>
+            <a:off x="822960" y="1874520"/>
+            <a:ext cx="10515600" cy="2468880"/>
+          </a:xfrm>
+          <a:prstGeom prst="roundRect">
+            <a:avLst>
+              <a:gd name="adj" fmla="val 2963"/>
+            </a:avLst>
+          </a:prstGeom>
+          <a:solidFill>
+            <a:srgbClr val="F4EEE4"/>
+          </a:solidFill>
+          <a:ln/>
+          <a:effectLst>
+            <a:outerShdw sx="100000" sy="100000" kx="0" ky="0" algn="bl" rotWithShape="0" blurRad="177800" dist="50800" dir="5400000">
+              <a:srgbClr val="000000">
+                <a:alpha val="6000"/>
+              </a:srgbClr>
+            </a:outerShdw>
+          </a:effectLst>
+        </p:spPr>
+      </p:sp>
+      <p:sp>
+        <p:nvSpPr>
+          <p:cNvPr id="5" name="Text 3"/>
+          <p:cNvSpPr/>
+          <p:nvPr/>
+        </p:nvSpPr>
+        <p:spPr>
+          <a:xfrm>
+            <a:off x="1143000" y="2084832"/>
+            <a:ext cx="3657600" cy="274320"/>
+          </a:xfrm>
+          <a:prstGeom prst="rect">
+            <a:avLst/>
+          </a:prstGeom>
+          <a:noFill/>
+          <a:ln/>
+        </p:spPr>
+        <p:txBody>
+          <a:bodyPr wrap="square" rtlCol="0" anchor="ctr"/>
+          <a:lstStyle/>
+          <a:p>
+            <a:pPr indent="0" marL="0">
+              <a:buNone/>
+            </a:pPr>
+            <a:r>
+              <a:rPr lang="en-US" sz="1000" spc="200" kern="0" dirty="0">
+                <a:solidFill>
+                  <a:srgbClr val="766D63"/>
+                </a:solidFill>
+                <a:latin typeface="Calibri" pitchFamily="34" charset="0"/>
+                <a:ea typeface="Calibri" pitchFamily="34" charset="-122"/>
+                <a:cs typeface="Calibri" pitchFamily="34" charset="-120"/>
+              </a:rPr>
+              <a:t>BUTTONS</a:t>
+            </a:r>
+            <a:endParaRPr lang="en-US" sz="1000" dirty="0"/>
+          </a:p>
+        </p:txBody>
+      </p:sp>
+      <p:sp>
+        <p:nvSpPr>
+          <p:cNvPr id="6" name="Shape 4"/>
+          <p:cNvSpPr/>
+          <p:nvPr/>
+        </p:nvSpPr>
+        <p:spPr>
+          <a:xfrm>
+            <a:off x="1143000" y="2450592"/>
+            <a:ext cx="2651760" cy="566928"/>
+          </a:xfrm>
+          <a:prstGeom prst="roundRect">
+            <a:avLst>
+              <a:gd name="adj" fmla="val 50000"/>
+            </a:avLst>
+          </a:prstGeom>
+          <a:solidFill>
+            <a:srgbClr val="2A2219"/>
+          </a:solidFill>
+          <a:ln/>
+        </p:spPr>
+      </p:sp>
+      <p:sp>
+        <p:nvSpPr>
+          <p:cNvPr id="7" name="Text 5"/>
+          <p:cNvSpPr/>
+          <p:nvPr/>
+        </p:nvSpPr>
+        <p:spPr>
+          <a:xfrm>
+            <a:off x="1143000" y="2450592"/>
+            <a:ext cx="2651760" cy="566928"/>
+          </a:xfrm>
+          <a:prstGeom prst="rect">
+            <a:avLst/>
+          </a:prstGeom>
+          <a:noFill/>
+          <a:ln/>
+        </p:spPr>
+        <p:txBody>
+          <a:bodyPr wrap="square" lIns="0" tIns="0" rIns="0" bIns="0" rtlCol="0" anchor="ctr"/>
+          <a:lstStyle/>
+          <a:p>
+            <a:pPr algn="ctr" indent="0" marL="0">
+              <a:buNone/>
+            </a:pPr>
+            <a:r>
+              <a:rPr lang="en-US" sz="1050" spc="100" kern="0" dirty="0">
+                <a:solidFill>
+                  <a:srgbClr val="FBF7EF"/>
+                </a:solidFill>
+                <a:latin typeface="Calibri" pitchFamily="34" charset="0"/>
+                <a:ea typeface="Calibri" pitchFamily="34" charset="-122"/>
+                <a:cs typeface="Calibri" pitchFamily="34" charset="-120"/>
+              </a:rPr>
+              <a:t>REQUEST A BRIEFING</a:t>
+            </a:r>
+            <a:endParaRPr lang="en-US" sz="1050" dirty="0"/>
+          </a:p>
+        </p:txBody>
+      </p:sp>
+      <p:sp>
+        <p:nvSpPr>
+          <p:cNvPr id="8" name="Shape 6"/>
+          <p:cNvSpPr/>
+          <p:nvPr/>
+        </p:nvSpPr>
+        <p:spPr>
+          <a:xfrm>
+            <a:off x="3977640" y="2450592"/>
+            <a:ext cx="2286000" cy="566928"/>
+          </a:xfrm>
+          <a:prstGeom prst="roundRect">
+            <a:avLst>
+              <a:gd name="adj" fmla="val 50000"/>
+            </a:avLst>
+          </a:prstGeom>
+          <a:ln w="15875">
+            <a:solidFill>
+              <a:srgbClr val="9B6B3D"/>
+            </a:solidFill>
+            <a:prstDash val="solid"/>
+          </a:ln>
+        </p:spPr>
+      </p:sp>
+      <p:sp>
+        <p:nvSpPr>
+          <p:cNvPr id="9" name="Text 7"/>
+          <p:cNvSpPr/>
+          <p:nvPr/>
+        </p:nvSpPr>
+        <p:spPr>
+          <a:xfrm>
+            <a:off x="3977640" y="2450592"/>
+            <a:ext cx="2286000" cy="566928"/>
+          </a:xfrm>
+          <a:prstGeom prst="rect">
+            <a:avLst/>
+          </a:prstGeom>
+          <a:noFill/>
+          <a:ln/>
+        </p:spPr>
+        <p:txBody>
+          <a:bodyPr wrap="square" lIns="0" tIns="0" rIns="0" bIns="0" rtlCol="0" anchor="ctr"/>
+          <a:lstStyle/>
+          <a:p>
+            <a:pPr algn="ctr" indent="0" marL="0">
+              <a:buNone/>
+            </a:pPr>
+            <a:r>
+              <a:rPr lang="en-US" sz="1050" spc="100" kern="0" dirty="0">
+                <a:solidFill>
+                  <a:srgbClr val="9B6B3D"/>
+                </a:solidFill>
+                <a:latin typeface="Calibri" pitchFamily="34" charset="0"/>
+                <a:ea typeface="Calibri" pitchFamily="34" charset="-122"/>
+                <a:cs typeface="Calibri" pitchFamily="34" charset="-120"/>
+              </a:rPr>
+              <a:t>VIEW PROJECTS</a:t>
+            </a:r>
+            <a:endParaRPr lang="en-US" sz="1050" dirty="0"/>
+          </a:p>
+        </p:txBody>
+      </p:sp>
+      <p:sp>
+        <p:nvSpPr>
+          <p:cNvPr id="10" name="Shape 8"/>
+          <p:cNvSpPr/>
+          <p:nvPr/>
+        </p:nvSpPr>
+        <p:spPr>
+          <a:xfrm>
+            <a:off x="6446520" y="2450592"/>
+            <a:ext cx="1874520" cy="566928"/>
+          </a:xfrm>
+          <a:prstGeom prst="roundRect">
+            <a:avLst>
+              <a:gd name="adj" fmla="val 50000"/>
+            </a:avLst>
+          </a:prstGeom>
+          <a:ln w="12700">
+            <a:solidFill>
+              <a:srgbClr val="EBE3D4"/>
+            </a:solidFill>
+            <a:prstDash val="solid"/>
+          </a:ln>
+        </p:spPr>
+      </p:sp>
+      <p:sp>
+        <p:nvSpPr>
+          <p:cNvPr id="11" name="Text 9"/>
+          <p:cNvSpPr/>
+          <p:nvPr/>
+        </p:nvSpPr>
+        <p:spPr>
+          <a:xfrm>
+            <a:off x="6446520" y="2450592"/>
+            <a:ext cx="1874520" cy="566928"/>
+          </a:xfrm>
+          <a:prstGeom prst="rect">
+            <a:avLst/>
+          </a:prstGeom>
+          <a:noFill/>
+          <a:ln/>
+        </p:spPr>
+        <p:txBody>
+          <a:bodyPr wrap="square" lIns="0" tIns="0" rIns="0" bIns="0" rtlCol="0" anchor="ctr"/>
+          <a:lstStyle/>
+          <a:p>
+            <a:pPr algn="ctr" indent="0" marL="0">
+              <a:buNone/>
+            </a:pPr>
+            <a:r>
+              <a:rPr lang="en-US" sz="1050" spc="100" kern="0" dirty="0">
+                <a:solidFill>
+                  <a:srgbClr val="5C534A"/>
+                </a:solidFill>
+                <a:latin typeface="Calibri" pitchFamily="34" charset="0"/>
+                <a:ea typeface="Calibri" pitchFamily="34" charset="-122"/>
+                <a:cs typeface="Calibri" pitchFamily="34" charset="-120"/>
+              </a:rPr>
+              <a:t>LEARN MORE</a:t>
+            </a:r>
+            <a:endParaRPr lang="en-US" sz="1050" dirty="0"/>
+          </a:p>
+        </p:txBody>
+      </p:sp>
+      <p:sp>
+        <p:nvSpPr>
+          <p:cNvPr id="12" name="Text 10"/>
+          <p:cNvSpPr/>
+          <p:nvPr/>
+        </p:nvSpPr>
+        <p:spPr>
+          <a:xfrm>
+            <a:off x="8595360" y="2450592"/>
+            <a:ext cx="2468880" cy="566928"/>
+          </a:xfrm>
+          <a:prstGeom prst="rect">
+            <a:avLst/>
+          </a:prstGeom>
+          <a:noFill/>
+          <a:ln/>
+        </p:spPr>
+        <p:txBody>
+          <a:bodyPr wrap="square" rtlCol="0" anchor="ctr"/>
+          <a:lstStyle/>
+          <a:p>
+            <a:pPr indent="0" marL="0">
+              <a:buNone/>
+            </a:pPr>
+            <a:r>
+              <a:rPr lang="en-US" sz="1100" i="1" dirty="0">
+                <a:solidFill>
+                  <a:srgbClr val="766D63"/>
+                </a:solidFill>
+                <a:latin typeface="Calibri" pitchFamily="34" charset="0"/>
+                <a:ea typeface="Calibri" pitchFamily="34" charset="-122"/>
+                <a:cs typeface="Calibri" pitchFamily="34" charset="-120"/>
+              </a:rPr>
+              <a:t>Solid · Outline · Ghost</a:t>
+            </a:r>
+            <a:endParaRPr lang="en-US" sz="1100" dirty="0"/>
+          </a:p>
+        </p:txBody>
+      </p:sp>
+      <p:sp>
+        <p:nvSpPr>
+          <p:cNvPr id="13" name="Text 11"/>
+          <p:cNvSpPr/>
+          <p:nvPr/>
+        </p:nvSpPr>
+        <p:spPr>
+          <a:xfrm>
+            <a:off x="1143000" y="3310128"/>
+            <a:ext cx="3657600" cy="274320"/>
+          </a:xfrm>
+          <a:prstGeom prst="rect">
+            <a:avLst/>
+          </a:prstGeom>
+          <a:noFill/>
+          <a:ln/>
+        </p:spPr>
+        <p:txBody>
+          <a:bodyPr wrap="square" rtlCol="0" anchor="ctr"/>
+          <a:lstStyle/>
+          <a:p>
+            <a:pPr indent="0" marL="0">
+              <a:buNone/>
+            </a:pPr>
+            <a:r>
+              <a:rPr lang="en-US" sz="1000" spc="200" kern="0" dirty="0">
+                <a:solidFill>
+                  <a:srgbClr val="766D63"/>
+                </a:solidFill>
+                <a:latin typeface="Calibri" pitchFamily="34" charset="0"/>
+                <a:ea typeface="Calibri" pitchFamily="34" charset="-122"/>
+                <a:cs typeface="Calibri" pitchFamily="34" charset="-120"/>
+              </a:rPr>
+              <a:t>TOPIC PILLS</a:t>
+            </a:r>
+            <a:endParaRPr lang="en-US" sz="1000" dirty="0"/>
+          </a:p>
+        </p:txBody>
+      </p:sp>
+      <p:sp>
+        <p:nvSpPr>
+          <p:cNvPr id="14" name="Shape 12"/>
+          <p:cNvSpPr/>
+          <p:nvPr/>
+        </p:nvSpPr>
+        <p:spPr>
+          <a:xfrm>
+            <a:off x="1143000" y="3657600"/>
+            <a:ext cx="1179576" cy="420624"/>
+          </a:xfrm>
+          <a:prstGeom prst="roundRect">
+            <a:avLst>
+              <a:gd name="adj" fmla="val 50000"/>
+            </a:avLst>
+          </a:prstGeom>
+          <a:solidFill>
+            <a:srgbClr val="DFC58C">
+              <a:alpha val="35000"/>
+            </a:srgbClr>
+          </a:solidFill>
+          <a:ln w="9525">
+            <a:solidFill>
+              <a:srgbClr val="C7A46A"/>
+            </a:solidFill>
+            <a:prstDash val="solid"/>
+          </a:ln>
+        </p:spPr>
+      </p:sp>
+      <p:sp>
+        <p:nvSpPr>
+          <p:cNvPr id="15" name="Text 13"/>
+          <p:cNvSpPr/>
+          <p:nvPr/>
+        </p:nvSpPr>
+        <p:spPr>
+          <a:xfrm>
+            <a:off x="1143000" y="3657600"/>
+            <a:ext cx="1179576" cy="420624"/>
+          </a:xfrm>
+          <a:prstGeom prst="rect">
+            <a:avLst/>
+          </a:prstGeom>
+          <a:noFill/>
+          <a:ln/>
+        </p:spPr>
+        <p:txBody>
+          <a:bodyPr wrap="square" lIns="0" tIns="0" rIns="0" bIns="0" rtlCol="0" anchor="ctr"/>
+          <a:lstStyle/>
+          <a:p>
+            <a:pPr algn="ctr" indent="0" marL="0">
+              <a:buNone/>
+            </a:pPr>
+            <a:r>
+              <a:rPr lang="en-US" sz="950" spc="100" kern="0" dirty="0">
+                <a:solidFill>
+                  <a:srgbClr val="7A4728"/>
+                </a:solidFill>
+                <a:latin typeface="Calibri" pitchFamily="34" charset="0"/>
+                <a:ea typeface="Calibri" pitchFamily="34" charset="-122"/>
+                <a:cs typeface="Calibri" pitchFamily="34" charset="-120"/>
+              </a:rPr>
+              <a:t>HEALTHCARE</a:t>
+            </a:r>
+            <a:endParaRPr lang="en-US" sz="950" dirty="0"/>
+          </a:p>
+        </p:txBody>
+      </p:sp>
+      <p:sp>
+        <p:nvSpPr>
+          <p:cNvPr id="16" name="Shape 14"/>
+          <p:cNvSpPr/>
+          <p:nvPr/>
+        </p:nvSpPr>
+        <p:spPr>
+          <a:xfrm>
+            <a:off x="2523744" y="3657600"/>
+            <a:ext cx="1100023" cy="420624"/>
+          </a:xfrm>
+          <a:prstGeom prst="roundRect">
+            <a:avLst>
+              <a:gd name="adj" fmla="val 50000"/>
+            </a:avLst>
+          </a:prstGeom>
+          <a:solidFill>
+            <a:srgbClr val="DFC58C">
+              <a:alpha val="35000"/>
+            </a:srgbClr>
+          </a:solidFill>
+          <a:ln w="9525">
+            <a:solidFill>
+              <a:srgbClr val="C7A46A"/>
+            </a:solidFill>
+            <a:prstDash val="solid"/>
+          </a:ln>
+        </p:spPr>
+      </p:sp>
+      <p:sp>
+        <p:nvSpPr>
+          <p:cNvPr id="17" name="Text 15"/>
+          <p:cNvSpPr/>
+          <p:nvPr/>
+        </p:nvSpPr>
+        <p:spPr>
+          <a:xfrm>
+            <a:off x="2523744" y="3657600"/>
+            <a:ext cx="1100023" cy="420624"/>
+          </a:xfrm>
+          <a:prstGeom prst="rect">
+            <a:avLst/>
+          </a:prstGeom>
+          <a:noFill/>
+          <a:ln/>
+        </p:spPr>
+        <p:txBody>
+          <a:bodyPr wrap="square" lIns="0" tIns="0" rIns="0" bIns="0" rtlCol="0" anchor="ctr"/>
+          <a:lstStyle/>
+          <a:p>
+            <a:pPr algn="ctr" indent="0" marL="0">
+              <a:buNone/>
+            </a:pPr>
+            <a:r>
+              <a:rPr lang="en-US" sz="950" spc="100" kern="0" dirty="0">
+                <a:solidFill>
+                  <a:srgbClr val="7A4728"/>
+                </a:solidFill>
+                <a:latin typeface="Calibri" pitchFamily="34" charset="0"/>
+                <a:ea typeface="Calibri" pitchFamily="34" charset="-122"/>
+                <a:cs typeface="Calibri" pitchFamily="34" charset="-120"/>
+              </a:rPr>
+              <a:t>WORKPLACE</a:t>
+            </a:r>
+            <a:endParaRPr lang="en-US" sz="950" dirty="0"/>
+          </a:p>
+        </p:txBody>
+      </p:sp>
+      <p:sp>
+        <p:nvSpPr>
+          <p:cNvPr id="18" name="Shape 16"/>
+          <p:cNvSpPr/>
+          <p:nvPr/>
+        </p:nvSpPr>
+        <p:spPr>
+          <a:xfrm>
+            <a:off x="3824935" y="3657600"/>
+            <a:ext cx="1020470" cy="420624"/>
+          </a:xfrm>
+          <a:prstGeom prst="roundRect">
+            <a:avLst>
+              <a:gd name="adj" fmla="val 50000"/>
+            </a:avLst>
+          </a:prstGeom>
+          <a:solidFill>
+            <a:srgbClr val="DFC58C">
+              <a:alpha val="35000"/>
+            </a:srgbClr>
+          </a:solidFill>
+          <a:ln w="9525">
+            <a:solidFill>
+              <a:srgbClr val="C7A46A"/>
+            </a:solidFill>
+            <a:prstDash val="solid"/>
+          </a:ln>
+        </p:spPr>
+      </p:sp>
+      <p:sp>
+        <p:nvSpPr>
+          <p:cNvPr id="19" name="Text 17"/>
+          <p:cNvSpPr/>
+          <p:nvPr/>
+        </p:nvSpPr>
+        <p:spPr>
+          <a:xfrm>
+            <a:off x="3824935" y="3657600"/>
+            <a:ext cx="1020470" cy="420624"/>
+          </a:xfrm>
+          <a:prstGeom prst="rect">
+            <a:avLst/>
+          </a:prstGeom>
+          <a:noFill/>
+          <a:ln/>
+        </p:spPr>
+        <p:txBody>
+          <a:bodyPr wrap="square" lIns="0" tIns="0" rIns="0" bIns="0" rtlCol="0" anchor="ctr"/>
+          <a:lstStyle/>
+          <a:p>
+            <a:pPr algn="ctr" indent="0" marL="0">
+              <a:buNone/>
+            </a:pPr>
+            <a:r>
+              <a:rPr lang="en-US" sz="950" spc="100" kern="0" dirty="0">
+                <a:solidFill>
+                  <a:srgbClr val="7A4728"/>
+                </a:solidFill>
+                <a:latin typeface="Calibri" pitchFamily="34" charset="0"/>
+                <a:ea typeface="Calibri" pitchFamily="34" charset="-122"/>
+                <a:cs typeface="Calibri" pitchFamily="34" charset="-120"/>
+              </a:rPr>
+              <a:t>DELIVERY</a:t>
+            </a:r>
+            <a:endParaRPr lang="en-US" sz="950" dirty="0"/>
+          </a:p>
+        </p:txBody>
+      </p:sp>
+      <p:sp>
+        <p:nvSpPr>
+          <p:cNvPr id="20" name="Shape 18"/>
+          <p:cNvSpPr/>
+          <p:nvPr/>
+        </p:nvSpPr>
+        <p:spPr>
+          <a:xfrm>
+            <a:off x="5046574" y="3657600"/>
+            <a:ext cx="861365" cy="420624"/>
+          </a:xfrm>
+          <a:prstGeom prst="roundRect">
+            <a:avLst>
+              <a:gd name="adj" fmla="val 50000"/>
+            </a:avLst>
+          </a:prstGeom>
+          <a:solidFill>
+            <a:srgbClr val="DFC58C">
+              <a:alpha val="35000"/>
+            </a:srgbClr>
+          </a:solidFill>
+          <a:ln w="9525">
+            <a:solidFill>
+              <a:srgbClr val="C7A46A"/>
+            </a:solidFill>
+            <a:prstDash val="solid"/>
+          </a:ln>
+        </p:spPr>
+      </p:sp>
+      <p:sp>
+        <p:nvSpPr>
+          <p:cNvPr id="21" name="Text 19"/>
+          <p:cNvSpPr/>
+          <p:nvPr/>
+        </p:nvSpPr>
+        <p:spPr>
+          <a:xfrm>
+            <a:off x="5046574" y="3657600"/>
+            <a:ext cx="861365" cy="420624"/>
+          </a:xfrm>
+          <a:prstGeom prst="rect">
+            <a:avLst/>
+          </a:prstGeom>
+          <a:noFill/>
+          <a:ln/>
+        </p:spPr>
+        <p:txBody>
+          <a:bodyPr wrap="square" lIns="0" tIns="0" rIns="0" bIns="0" rtlCol="0" anchor="ctr"/>
+          <a:lstStyle/>
+          <a:p>
+            <a:pPr algn="ctr" indent="0" marL="0">
+              <a:buNone/>
+            </a:pPr>
+            <a:r>
+              <a:rPr lang="en-US" sz="950" spc="100" kern="0" dirty="0">
+                <a:solidFill>
+                  <a:srgbClr val="7A4728"/>
+                </a:solidFill>
+                <a:latin typeface="Calibri" pitchFamily="34" charset="0"/>
+                <a:ea typeface="Calibri" pitchFamily="34" charset="-122"/>
+                <a:cs typeface="Calibri" pitchFamily="34" charset="-120"/>
+              </a:rPr>
+              <a:t>RETAIL</a:t>
+            </a:r>
+            <a:endParaRPr lang="en-US" sz="950" dirty="0"/>
+          </a:p>
+        </p:txBody>
+      </p:sp>
+      <p:sp>
+        <p:nvSpPr>
+          <p:cNvPr id="22" name="Shape 20"/>
+          <p:cNvSpPr/>
+          <p:nvPr/>
+        </p:nvSpPr>
+        <p:spPr>
+          <a:xfrm>
+            <a:off x="822960" y="4526280"/>
+            <a:ext cx="5120640" cy="1874520"/>
+          </a:xfrm>
+          <a:prstGeom prst="roundRect">
+            <a:avLst>
+              <a:gd name="adj" fmla="val 3902"/>
+            </a:avLst>
+          </a:prstGeom>
+          <a:solidFill>
+            <a:srgbClr val="F4EEE4"/>
+          </a:solidFill>
+          <a:ln/>
+          <a:effectLst>
+            <a:outerShdw sx="100000" sy="100000" kx="0" ky="0" algn="bl" rotWithShape="0" blurRad="177800" dist="50800" dir="5400000">
+              <a:srgbClr val="000000">
+                <a:alpha val="6000"/>
+              </a:srgbClr>
+            </a:outerShdw>
+          </a:effectLst>
+        </p:spPr>
+      </p:sp>
+      <p:sp>
+        <p:nvSpPr>
+          <p:cNvPr id="23" name="Text 21"/>
+          <p:cNvSpPr/>
+          <p:nvPr/>
+        </p:nvSpPr>
+        <p:spPr>
+          <a:xfrm>
+            <a:off x="1143000" y="4736592"/>
+            <a:ext cx="3657600" cy="274320"/>
+          </a:xfrm>
+          <a:prstGeom prst="rect">
+            <a:avLst/>
+          </a:prstGeom>
+          <a:noFill/>
+          <a:ln/>
+        </p:spPr>
+        <p:txBody>
+          <a:bodyPr wrap="square" rtlCol="0" anchor="ctr"/>
+          <a:lstStyle/>
+          <a:p>
+            <a:pPr indent="0" marL="0">
+              <a:buNone/>
+            </a:pPr>
+            <a:r>
+              <a:rPr lang="en-US" sz="1000" spc="200" kern="0" dirty="0">
+                <a:solidFill>
+                  <a:srgbClr val="766D63"/>
+                </a:solidFill>
+                <a:latin typeface="Calibri" pitchFamily="34" charset="0"/>
+                <a:ea typeface="Calibri" pitchFamily="34" charset="-122"/>
+                <a:cs typeface="Calibri" pitchFamily="34" charset="-120"/>
+              </a:rPr>
+              <a:t>FOCUS RING</a:t>
+            </a:r>
+            <a:endParaRPr lang="en-US" sz="1000" dirty="0"/>
+          </a:p>
+        </p:txBody>
+      </p:sp>
+      <p:sp>
+        <p:nvSpPr>
+          <p:cNvPr id="24" name="Shape 22"/>
+          <p:cNvSpPr/>
+          <p:nvPr/>
+        </p:nvSpPr>
+        <p:spPr>
+          <a:xfrm>
+            <a:off x="1143000" y="5120640"/>
+            <a:ext cx="2377440" cy="457200"/>
+          </a:xfrm>
+          <a:prstGeom prst="roundRect">
+            <a:avLst>
+              <a:gd name="adj" fmla="val 16000"/>
+            </a:avLst>
+          </a:prstGeom>
+          <a:solidFill>
+            <a:srgbClr val="FBF7EF"/>
+          </a:solidFill>
+          <a:ln w="19050">
+            <a:solidFill>
+              <a:srgbClr val="C7A46A"/>
+            </a:solidFill>
+            <a:prstDash val="solid"/>
+          </a:ln>
+        </p:spPr>
+      </p:sp>
+      <p:sp>
+        <p:nvSpPr>
+          <p:cNvPr id="25" name="Text 23"/>
+          <p:cNvSpPr/>
+          <p:nvPr/>
+        </p:nvSpPr>
+        <p:spPr>
+          <a:xfrm>
+            <a:off x="1143000" y="5120640"/>
+            <a:ext cx="2377440" cy="457200"/>
+          </a:xfrm>
+          <a:prstGeom prst="rect">
+            <a:avLst/>
+          </a:prstGeom>
+          <a:noFill/>
+          <a:ln/>
+        </p:spPr>
+        <p:txBody>
+          <a:bodyPr wrap="square" lIns="0" tIns="0" rIns="0" bIns="0" rtlCol="0" anchor="ctr"/>
+          <a:lstStyle/>
+          <a:p>
+            <a:pPr algn="ctr" indent="0" marL="0">
+              <a:buNone/>
+            </a:pPr>
+            <a:r>
+              <a:rPr lang="en-US" sz="1050" dirty="0">
+                <a:solidFill>
+                  <a:srgbClr val="2F291F"/>
+                </a:solidFill>
+                <a:latin typeface="Calibri" pitchFamily="34" charset="0"/>
+                <a:ea typeface="Calibri" pitchFamily="34" charset="-122"/>
+                <a:cs typeface="Calibri" pitchFamily="34" charset="-120"/>
+              </a:rPr>
+              <a:t>Interactive element</a:t>
+            </a:r>
+            <a:endParaRPr lang="en-US" sz="1050" dirty="0"/>
+          </a:p>
+        </p:txBody>
+      </p:sp>
+      <p:sp>
+        <p:nvSpPr>
+          <p:cNvPr id="26" name="Text 24"/>
+          <p:cNvSpPr/>
+          <p:nvPr/>
+        </p:nvSpPr>
+        <p:spPr>
+          <a:xfrm>
+            <a:off x="1143000" y="5742432"/>
+            <a:ext cx="3657600" cy="320040"/>
+          </a:xfrm>
+          <a:prstGeom prst="rect">
+            <a:avLst/>
+          </a:prstGeom>
+          <a:noFill/>
+          <a:ln/>
+        </p:spPr>
+        <p:txBody>
+          <a:bodyPr wrap="square" rtlCol="0" anchor="ctr"/>
+          <a:lstStyle/>
+          <a:p>
+            <a:pPr indent="0" marL="0">
+              <a:buNone/>
+            </a:pPr>
+            <a:r>
+              <a:rPr lang="en-US" sz="1000" i="1" dirty="0">
+                <a:solidFill>
+                  <a:srgbClr val="766D63"/>
+                </a:solidFill>
+                <a:latin typeface="Calibri" pitchFamily="34" charset="0"/>
+                <a:ea typeface="Calibri" pitchFamily="34" charset="-122"/>
+                <a:cs typeface="Calibri" pitchFamily="34" charset="-120"/>
+              </a:rPr>
+              <a:t>2px solid gold · 3px offset</a:t>
+            </a:r>
+            <a:endParaRPr lang="en-US" sz="1000" dirty="0"/>
+          </a:p>
+        </p:txBody>
+      </p:sp>
+      <p:sp>
+        <p:nvSpPr>
+          <p:cNvPr id="27" name="Shape 25"/>
+          <p:cNvSpPr/>
+          <p:nvPr/>
+        </p:nvSpPr>
+        <p:spPr>
+          <a:xfrm>
+            <a:off x="6217920" y="4526280"/>
+            <a:ext cx="5120640" cy="1874520"/>
+          </a:xfrm>
+          <a:prstGeom prst="roundRect">
+            <a:avLst>
+              <a:gd name="adj" fmla="val 3902"/>
+            </a:avLst>
+          </a:prstGeom>
+          <a:solidFill>
+            <a:srgbClr val="F4EEE4"/>
+          </a:solidFill>
+          <a:ln/>
+          <a:effectLst>
+            <a:outerShdw sx="100000" sy="100000" kx="0" ky="0" algn="bl" rotWithShape="0" blurRad="177800" dist="50800" dir="5400000">
+              <a:srgbClr val="000000">
+                <a:alpha val="6000"/>
+              </a:srgbClr>
+            </a:outerShdw>
+          </a:effectLst>
+        </p:spPr>
+      </p:sp>
+      <p:sp>
+        <p:nvSpPr>
+          <p:cNvPr id="28" name="Text 26"/>
+          <p:cNvSpPr/>
+          <p:nvPr/>
+        </p:nvSpPr>
+        <p:spPr>
+          <a:xfrm>
+            <a:off x="6537960" y="4736592"/>
+            <a:ext cx="3657600" cy="274320"/>
+          </a:xfrm>
+          <a:prstGeom prst="rect">
+            <a:avLst/>
+          </a:prstGeom>
+          <a:noFill/>
+          <a:ln/>
+        </p:spPr>
+        <p:txBody>
+          <a:bodyPr wrap="square" rtlCol="0" anchor="ctr"/>
+          <a:lstStyle/>
+          <a:p>
+            <a:pPr indent="0" marL="0">
+              <a:buNone/>
+            </a:pPr>
+            <a:r>
+              <a:rPr lang="en-US" sz="1000" spc="200" kern="0" dirty="0">
+                <a:solidFill>
+                  <a:srgbClr val="766D63"/>
+                </a:solidFill>
+                <a:latin typeface="Calibri" pitchFamily="34" charset="0"/>
+                <a:ea typeface="Calibri" pitchFamily="34" charset="-122"/>
+                <a:cs typeface="Calibri" pitchFamily="34" charset="-120"/>
+              </a:rPr>
+              <a:t>BORDER RADII</a:t>
+            </a:r>
+            <a:endParaRPr lang="en-US" sz="1000" dirty="0"/>
+          </a:p>
+        </p:txBody>
+      </p:sp>
+      <p:sp>
+        <p:nvSpPr>
+          <p:cNvPr id="29" name="Shape 27"/>
+          <p:cNvSpPr/>
+          <p:nvPr/>
+        </p:nvSpPr>
+        <p:spPr>
+          <a:xfrm>
+            <a:off x="6537960" y="5138928"/>
+            <a:ext cx="777240" cy="594360"/>
+          </a:xfrm>
+          <a:prstGeom prst="roundRect">
+            <a:avLst>
+              <a:gd name="adj" fmla="val 6154"/>
+            </a:avLst>
+          </a:prstGeom>
+          <a:solidFill>
+            <a:srgbClr val="EBE3D4"/>
+          </a:solidFill>
+          <a:ln/>
+        </p:spPr>
+      </p:sp>
+      <p:sp>
+        <p:nvSpPr>
+          <p:cNvPr id="30" name="Text 28"/>
+          <p:cNvSpPr/>
+          <p:nvPr/>
+        </p:nvSpPr>
+        <p:spPr>
+          <a:xfrm>
+            <a:off x="6537960" y="5806440"/>
+            <a:ext cx="777240" cy="274320"/>
+          </a:xfrm>
+          <a:prstGeom prst="rect">
+            <a:avLst/>
+          </a:prstGeom>
+          <a:noFill/>
+          <a:ln/>
+        </p:spPr>
+        <p:txBody>
+          <a:bodyPr wrap="square" lIns="0" tIns="0" rIns="0" bIns="0" rtlCol="0" anchor="ctr"/>
+          <a:lstStyle/>
+          <a:p>
+            <a:pPr algn="ctr" indent="0" marL="0">
+              <a:buNone/>
+            </a:pPr>
+            <a:r>
+              <a:rPr lang="en-US" sz="950" dirty="0">
+                <a:solidFill>
+                  <a:srgbClr val="766D63"/>
+                </a:solidFill>
+                <a:latin typeface="Calibri" pitchFamily="34" charset="0"/>
+                <a:ea typeface="Calibri" pitchFamily="34" charset="-122"/>
+                <a:cs typeface="Calibri" pitchFamily="34" charset="-120"/>
+              </a:rPr>
+              <a:t>4px</a:t>
+            </a:r>
+            <a:endParaRPr lang="en-US" sz="950" dirty="0"/>
+          </a:p>
+        </p:txBody>
+      </p:sp>
+      <p:sp>
+        <p:nvSpPr>
+          <p:cNvPr id="31" name="Shape 29"/>
+          <p:cNvSpPr/>
+          <p:nvPr/>
+        </p:nvSpPr>
+        <p:spPr>
+          <a:xfrm>
+            <a:off x="7571232" y="5138928"/>
+            <a:ext cx="777240" cy="594360"/>
+          </a:xfrm>
+          <a:prstGeom prst="roundRect">
+            <a:avLst>
+              <a:gd name="adj" fmla="val 13846"/>
+            </a:avLst>
+          </a:prstGeom>
+          <a:solidFill>
+            <a:srgbClr val="EBE3D4"/>
+          </a:solidFill>
+          <a:ln/>
+        </p:spPr>
+      </p:sp>
+      <p:sp>
+        <p:nvSpPr>
+          <p:cNvPr id="32" name="Text 30"/>
+          <p:cNvSpPr/>
+          <p:nvPr/>
+        </p:nvSpPr>
+        <p:spPr>
+          <a:xfrm>
+            <a:off x="7571232" y="5806440"/>
+            <a:ext cx="777240" cy="274320"/>
+          </a:xfrm>
+          <a:prstGeom prst="rect">
+            <a:avLst/>
+          </a:prstGeom>
+          <a:noFill/>
+          <a:ln/>
+        </p:spPr>
+        <p:txBody>
+          <a:bodyPr wrap="square" lIns="0" tIns="0" rIns="0" bIns="0" rtlCol="0" anchor="ctr"/>
+          <a:lstStyle/>
+          <a:p>
+            <a:pPr algn="ctr" indent="0" marL="0">
+              <a:buNone/>
+            </a:pPr>
+            <a:r>
+              <a:rPr lang="en-US" sz="950" dirty="0">
+                <a:solidFill>
+                  <a:srgbClr val="766D63"/>
+                </a:solidFill>
+                <a:latin typeface="Calibri" pitchFamily="34" charset="0"/>
+                <a:ea typeface="Calibri" pitchFamily="34" charset="-122"/>
+                <a:cs typeface="Calibri" pitchFamily="34" charset="-120"/>
+              </a:rPr>
+              <a:t>8px</a:t>
+            </a:r>
+            <a:endParaRPr lang="en-US" sz="950" dirty="0"/>
+          </a:p>
+        </p:txBody>
+      </p:sp>
+      <p:sp>
+        <p:nvSpPr>
+          <p:cNvPr id="33" name="Shape 31"/>
+          <p:cNvSpPr/>
+          <p:nvPr/>
+        </p:nvSpPr>
+        <p:spPr>
+          <a:xfrm>
+            <a:off x="8604504" y="5138928"/>
+            <a:ext cx="777240" cy="594360"/>
+          </a:xfrm>
+          <a:prstGeom prst="roundRect">
+            <a:avLst>
+              <a:gd name="adj" fmla="val 21538"/>
+            </a:avLst>
+          </a:prstGeom>
+          <a:solidFill>
+            <a:srgbClr val="EBE3D4"/>
+          </a:solidFill>
+          <a:ln/>
+        </p:spPr>
+      </p:sp>
+      <p:sp>
+        <p:nvSpPr>
+          <p:cNvPr id="34" name="Text 32"/>
+          <p:cNvSpPr/>
+          <p:nvPr/>
+        </p:nvSpPr>
+        <p:spPr>
+          <a:xfrm>
+            <a:off x="8604504" y="5806440"/>
+            <a:ext cx="777240" cy="274320"/>
+          </a:xfrm>
+          <a:prstGeom prst="rect">
+            <a:avLst/>
+          </a:prstGeom>
+          <a:noFill/>
+          <a:ln/>
+        </p:spPr>
+        <p:txBody>
+          <a:bodyPr wrap="square" lIns="0" tIns="0" rIns="0" bIns="0" rtlCol="0" anchor="ctr"/>
+          <a:lstStyle/>
+          <a:p>
+            <a:pPr algn="ctr" indent="0" marL="0">
+              <a:buNone/>
+            </a:pPr>
+            <a:r>
+              <a:rPr lang="en-US" sz="950" dirty="0">
+                <a:solidFill>
+                  <a:srgbClr val="766D63"/>
+                </a:solidFill>
+                <a:latin typeface="Calibri" pitchFamily="34" charset="0"/>
+                <a:ea typeface="Calibri" pitchFamily="34" charset="-122"/>
+                <a:cs typeface="Calibri" pitchFamily="34" charset="-120"/>
+              </a:rPr>
+              <a:t>12px</a:t>
+            </a:r>
+            <a:endParaRPr lang="en-US" sz="950" dirty="0"/>
+          </a:p>
+        </p:txBody>
+      </p:sp>
+      <p:sp>
+        <p:nvSpPr>
+          <p:cNvPr id="35" name="Shape 33"/>
+          <p:cNvSpPr/>
+          <p:nvPr/>
+        </p:nvSpPr>
+        <p:spPr>
+          <a:xfrm>
+            <a:off x="9637776" y="5138928"/>
+            <a:ext cx="1005840" cy="594360"/>
+          </a:xfrm>
+          <a:prstGeom prst="roundRect">
+            <a:avLst>
+              <a:gd name="adj" fmla="val 43077"/>
+            </a:avLst>
+          </a:prstGeom>
+          <a:solidFill>
+            <a:srgbClr val="EBE3D4"/>
+          </a:solidFill>
+          <a:ln/>
+        </p:spPr>
+      </p:sp>
+      <p:sp>
+        <p:nvSpPr>
+          <p:cNvPr id="36" name="Text 34"/>
+          <p:cNvSpPr/>
+          <p:nvPr/>
+        </p:nvSpPr>
+        <p:spPr>
+          <a:xfrm>
+            <a:off x="9637776" y="5806440"/>
+            <a:ext cx="1005840" cy="274320"/>
+          </a:xfrm>
+          <a:prstGeom prst="rect">
+            <a:avLst/>
+          </a:prstGeom>
+          <a:noFill/>
+          <a:ln/>
+        </p:spPr>
+        <p:txBody>
+          <a:bodyPr wrap="square" lIns="0" tIns="0" rIns="0" bIns="0" rtlCol="0" anchor="ctr"/>
+          <a:lstStyle/>
+          <a:p>
+            <a:pPr algn="ctr" indent="0" marL="0">
+              <a:buNone/>
+            </a:pPr>
+            <a:r>
+              <a:rPr lang="en-US" sz="950" dirty="0">
+                <a:solidFill>
+                  <a:srgbClr val="766D63"/>
+                </a:solidFill>
+                <a:latin typeface="Calibri" pitchFamily="34" charset="0"/>
+                <a:ea typeface="Calibri" pitchFamily="34" charset="-122"/>
+                <a:cs typeface="Calibri" pitchFamily="34" charset="-120"/>
+              </a:rPr>
+              <a:t>Pill</a:t>
+            </a:r>
+            <a:endParaRPr lang="en-US" sz="950" dirty="0"/>
+          </a:p>
+        </p:txBody>
+      </p:sp>
+    </p:spTree>
+  </p:cSld>
+  <p:clrMapOvr>
+    <a:masterClrMapping/>
+  </p:clrMapOvr>
+</p:sld>
+</file>
+
 <file path=ppt/slides/slide6.xml><?xml version="1.0" encoding="utf-8"?>
 <p:sld xmlns:a="http://schemas.openxmlformats.org/drawingml/2006/main" xmlns:r="http://schemas.openxmlformats.org/officeDocument/2006/relationships" xmlns:p="http://schemas.openxmlformats.org/presentationml/2006/main">
   <p:cSld name="Slide 6">
@@ -8169,518 +9369,6 @@
               <a:t>4.5–5.75rem</a:t>
             </a:r>
             <a:endParaRPr lang="en-US" sz="1900" dirty="0"/>
-          </a:p>
-        </p:txBody>
-      </p:sp>
-    </p:spTree>
-  </p:cSld>
-  <p:clrMapOvr>
-    <a:masterClrMapping/>
-  </p:clrMapOvr>
-</p:sld>
-</file>
-
-<file path=ppt/slides/slide7.xml><?xml version="1.0" encoding="utf-8"?>
-<p:sld xmlns:a="http://schemas.openxmlformats.org/drawingml/2006/main" xmlns:r="http://schemas.openxmlformats.org/officeDocument/2006/relationships" xmlns:p="http://schemas.openxmlformats.org/presentationml/2006/main">
-  <p:cSld name="Slide 7">
-    <p:bg>
-      <p:bgPr>
-        <a:solidFill>
-          <a:srgbClr val="2A2219"/>
-        </a:solidFill>
-      </p:bgPr>
-    </p:bg>
-    <p:spTree>
-      <p:nvGrpSpPr>
-        <p:cNvPr id="1" name=""/>
-        <p:cNvGrpSpPr/>
-        <p:nvPr/>
-      </p:nvGrpSpPr>
-      <p:grpSpPr>
-        <a:xfrm>
-          <a:off x="0" y="0"/>
-          <a:ext cx="0" cy="0"/>
-          <a:chOff x="0" y="0"/>
-          <a:chExt cx="0" cy="0"/>
-        </a:xfrm>
-      </p:grpSpPr>
-      <p:sp>
-        <p:nvSpPr>
-          <p:cNvPr id="2" name="Text 0"/>
-          <p:cNvSpPr/>
-          <p:nvPr/>
-        </p:nvSpPr>
-        <p:spPr>
-          <a:xfrm>
-            <a:off x="822960" y="502920"/>
-            <a:ext cx="7315200" cy="365760"/>
-          </a:xfrm>
-          <a:prstGeom prst="rect">
-            <a:avLst/>
-          </a:prstGeom>
-          <a:noFill/>
-          <a:ln/>
-        </p:spPr>
-        <p:txBody>
-          <a:bodyPr wrap="square" rtlCol="0" anchor="ctr"/>
-          <a:lstStyle/>
-          <a:p>
-            <a:pPr indent="0" marL="0">
-              <a:buNone/>
-            </a:pPr>
-            <a:r>
-              <a:rPr lang="en-US" sz="1200" spc="300" kern="0" dirty="0">
-                <a:solidFill>
-                  <a:srgbClr val="C7A46A"/>
-                </a:solidFill>
-                <a:latin typeface="Calibri" pitchFamily="34" charset="0"/>
-                <a:ea typeface="Calibri" pitchFamily="34" charset="-122"/>
-                <a:cs typeface="Calibri" pitchFamily="34" charset="-120"/>
-              </a:rPr>
-              <a:t>VISUAL LANGUAGE</a:t>
-            </a:r>
-            <a:endParaRPr lang="en-US" sz="1200" dirty="0"/>
-          </a:p>
-        </p:txBody>
-      </p:sp>
-      <p:sp>
-        <p:nvSpPr>
-          <p:cNvPr id="3" name="Text 1"/>
-          <p:cNvSpPr/>
-          <p:nvPr/>
-        </p:nvSpPr>
-        <p:spPr>
-          <a:xfrm>
-            <a:off x="777240" y="868680"/>
-            <a:ext cx="7315200" cy="822960"/>
-          </a:xfrm>
-          <a:prstGeom prst="rect">
-            <a:avLst/>
-          </a:prstGeom>
-          <a:noFill/>
-          <a:ln/>
-        </p:spPr>
-        <p:txBody>
-          <a:bodyPr wrap="square" lIns="0" tIns="0" rIns="0" bIns="0" rtlCol="0" anchor="ctr"/>
-          <a:lstStyle/>
-          <a:p>
-            <a:pPr indent="0" marL="0">
-              <a:buNone/>
-            </a:pPr>
-            <a:r>
-              <a:rPr lang="en-US" sz="3200" dirty="0">
-                <a:solidFill>
-                  <a:srgbClr val="FBF7EF"/>
-                </a:solidFill>
-                <a:latin typeface="Cambria" pitchFamily="34" charset="0"/>
-                <a:ea typeface="Cambria" pitchFamily="34" charset="-122"/>
-                <a:cs typeface="Cambria" pitchFamily="34" charset="-120"/>
-              </a:rPr>
-              <a:t>Warmth, light, restraint.</a:t>
-            </a:r>
-            <a:endParaRPr lang="en-US" sz="3200" dirty="0"/>
-          </a:p>
-        </p:txBody>
-      </p:sp>
-      <p:sp>
-        <p:nvSpPr>
-          <p:cNvPr id="4" name="Shape 2"/>
-          <p:cNvSpPr/>
-          <p:nvPr/>
-        </p:nvSpPr>
-        <p:spPr>
-          <a:xfrm>
-            <a:off x="7589520" y="1463040"/>
-            <a:ext cx="3749040" cy="4937760"/>
-          </a:xfrm>
-          <a:prstGeom prst="roundRect">
-            <a:avLst>
-              <a:gd name="adj" fmla="val 39024"/>
-            </a:avLst>
-          </a:prstGeom>
-          <a:solidFill>
-            <a:srgbClr val="DFC58C">
-              <a:alpha val="22000"/>
-            </a:srgbClr>
-          </a:solidFill>
-          <a:ln w="15875">
-            <a:solidFill>
-              <a:srgbClr val="C7A46A"/>
-            </a:solidFill>
-            <a:prstDash val="solid"/>
-          </a:ln>
-        </p:spPr>
-      </p:sp>
-      <p:sp>
-        <p:nvSpPr>
-          <p:cNvPr id="5" name="Shape 3"/>
-          <p:cNvSpPr/>
-          <p:nvPr/>
-        </p:nvSpPr>
-        <p:spPr>
-          <a:xfrm>
-            <a:off x="7909560" y="1737360"/>
-            <a:ext cx="0" cy="4389120"/>
-          </a:xfrm>
-          <a:prstGeom prst="line">
-            <a:avLst/>
-          </a:prstGeom>
-          <a:noFill/>
-          <a:ln w="12700">
-            <a:solidFill>
-              <a:srgbClr val="C7A46A">
-                <a:alpha val="70000"/>
-              </a:srgbClr>
-            </a:solidFill>
-            <a:prstDash val="solid"/>
-          </a:ln>
-        </p:spPr>
-      </p:sp>
-      <p:sp>
-        <p:nvSpPr>
-          <p:cNvPr id="6" name="Shape 4"/>
-          <p:cNvSpPr/>
-          <p:nvPr/>
-        </p:nvSpPr>
-        <p:spPr>
-          <a:xfrm>
-            <a:off x="8945880" y="1737360"/>
-            <a:ext cx="0" cy="4389120"/>
-          </a:xfrm>
-          <a:prstGeom prst="line">
-            <a:avLst/>
-          </a:prstGeom>
-          <a:noFill/>
-          <a:ln w="12700">
-            <a:solidFill>
-              <a:srgbClr val="C7A46A">
-                <a:alpha val="70000"/>
-              </a:srgbClr>
-            </a:solidFill>
-            <a:prstDash val="solid"/>
-          </a:ln>
-        </p:spPr>
-      </p:sp>
-      <p:sp>
-        <p:nvSpPr>
-          <p:cNvPr id="7" name="Shape 5"/>
-          <p:cNvSpPr/>
-          <p:nvPr/>
-        </p:nvSpPr>
-        <p:spPr>
-          <a:xfrm>
-            <a:off x="9982200" y="1737360"/>
-            <a:ext cx="0" cy="4389120"/>
-          </a:xfrm>
-          <a:prstGeom prst="line">
-            <a:avLst/>
-          </a:prstGeom>
-          <a:noFill/>
-          <a:ln w="12700">
-            <a:solidFill>
-              <a:srgbClr val="C7A46A">
-                <a:alpha val="70000"/>
-              </a:srgbClr>
-            </a:solidFill>
-            <a:prstDash val="solid"/>
-          </a:ln>
-        </p:spPr>
-      </p:sp>
-      <p:sp>
-        <p:nvSpPr>
-          <p:cNvPr id="8" name="Shape 6"/>
-          <p:cNvSpPr/>
-          <p:nvPr/>
-        </p:nvSpPr>
-        <p:spPr>
-          <a:xfrm>
-            <a:off x="7863840" y="3931920"/>
-            <a:ext cx="3200400" cy="0"/>
-          </a:xfrm>
-          <a:prstGeom prst="line">
-            <a:avLst/>
-          </a:prstGeom>
-          <a:noFill/>
-          <a:ln w="12700">
-            <a:solidFill>
-              <a:srgbClr val="C7A46A">
-                <a:alpha val="70000"/>
-              </a:srgbClr>
-            </a:solidFill>
-            <a:prstDash val="solid"/>
-          </a:ln>
-        </p:spPr>
-      </p:sp>
-      <p:sp>
-        <p:nvSpPr>
-          <p:cNvPr id="9" name="Text 7"/>
-          <p:cNvSpPr/>
-          <p:nvPr/>
-        </p:nvSpPr>
-        <p:spPr>
-          <a:xfrm>
-            <a:off x="914400" y="2011680"/>
-            <a:ext cx="5029200" cy="457200"/>
-          </a:xfrm>
-          <a:prstGeom prst="rect">
-            <a:avLst/>
-          </a:prstGeom>
-          <a:noFill/>
-          <a:ln/>
-        </p:spPr>
-        <p:txBody>
-          <a:bodyPr wrap="square" lIns="0" tIns="0" rIns="0" bIns="0" rtlCol="0" anchor="ctr"/>
-          <a:lstStyle/>
-          <a:p>
-            <a:pPr indent="0" marL="0">
-              <a:buNone/>
-            </a:pPr>
-            <a:r>
-              <a:rPr lang="en-US" sz="2400" i="1" dirty="0">
-                <a:solidFill>
-                  <a:srgbClr val="DFC58C"/>
-                </a:solidFill>
-                <a:latin typeface="Cambria" pitchFamily="34" charset="0"/>
-                <a:ea typeface="Cambria" pitchFamily="34" charset="-122"/>
-                <a:cs typeface="Cambria" pitchFamily="34" charset="-120"/>
-              </a:rPr>
-              <a:t>Editorial</a:t>
-            </a:r>
-            <a:endParaRPr lang="en-US" sz="2400" dirty="0"/>
-          </a:p>
-        </p:txBody>
-      </p:sp>
-      <p:sp>
-        <p:nvSpPr>
-          <p:cNvPr id="10" name="Text 8"/>
-          <p:cNvSpPr/>
-          <p:nvPr/>
-        </p:nvSpPr>
-        <p:spPr>
-          <a:xfrm>
-            <a:off x="914400" y="2514600"/>
-            <a:ext cx="6035040" cy="457200"/>
-          </a:xfrm>
-          <a:prstGeom prst="rect">
-            <a:avLst/>
-          </a:prstGeom>
-          <a:noFill/>
-          <a:ln/>
-        </p:spPr>
-        <p:txBody>
-          <a:bodyPr wrap="square" lIns="0" tIns="0" rIns="0" bIns="0" rtlCol="0" anchor="ctr"/>
-          <a:lstStyle/>
-          <a:p>
-            <a:pPr indent="0" marL="0">
-              <a:buNone/>
-            </a:pPr>
-            <a:r>
-              <a:rPr lang="en-US" sz="1250" dirty="0">
-                <a:solidFill>
-                  <a:srgbClr val="C9BEAE"/>
-                </a:solidFill>
-                <a:latin typeface="Calibri" pitchFamily="34" charset="0"/>
-                <a:ea typeface="Calibri" pitchFamily="34" charset="-122"/>
-                <a:cs typeface="Calibri" pitchFamily="34" charset="-120"/>
-              </a:rPr>
-              <a:t>Photography reads like a magazine spread, not a catalogue.</a:t>
-            </a:r>
-            <a:endParaRPr lang="en-US" sz="1250" dirty="0"/>
-          </a:p>
-        </p:txBody>
-      </p:sp>
-      <p:sp>
-        <p:nvSpPr>
-          <p:cNvPr id="11" name="Text 9"/>
-          <p:cNvSpPr/>
-          <p:nvPr/>
-        </p:nvSpPr>
-        <p:spPr>
-          <a:xfrm>
-            <a:off x="914400" y="3154680"/>
-            <a:ext cx="5029200" cy="457200"/>
-          </a:xfrm>
-          <a:prstGeom prst="rect">
-            <a:avLst/>
-          </a:prstGeom>
-          <a:noFill/>
-          <a:ln/>
-        </p:spPr>
-        <p:txBody>
-          <a:bodyPr wrap="square" lIns="0" tIns="0" rIns="0" bIns="0" rtlCol="0" anchor="ctr"/>
-          <a:lstStyle/>
-          <a:p>
-            <a:pPr indent="0" marL="0">
-              <a:buNone/>
-            </a:pPr>
-            <a:r>
-              <a:rPr lang="en-US" sz="2400" i="1" dirty="0">
-                <a:solidFill>
-                  <a:srgbClr val="DFC58C"/>
-                </a:solidFill>
-                <a:latin typeface="Cambria" pitchFamily="34" charset="0"/>
-                <a:ea typeface="Cambria" pitchFamily="34" charset="-122"/>
-                <a:cs typeface="Cambria" pitchFamily="34" charset="-120"/>
-              </a:rPr>
-              <a:t>Tactile</a:t>
-            </a:r>
-            <a:endParaRPr lang="en-US" sz="2400" dirty="0"/>
-          </a:p>
-        </p:txBody>
-      </p:sp>
-      <p:sp>
-        <p:nvSpPr>
-          <p:cNvPr id="12" name="Text 10"/>
-          <p:cNvSpPr/>
-          <p:nvPr/>
-        </p:nvSpPr>
-        <p:spPr>
-          <a:xfrm>
-            <a:off x="914400" y="3657600"/>
-            <a:ext cx="6035040" cy="457200"/>
-          </a:xfrm>
-          <a:prstGeom prst="rect">
-            <a:avLst/>
-          </a:prstGeom>
-          <a:noFill/>
-          <a:ln/>
-        </p:spPr>
-        <p:txBody>
-          <a:bodyPr wrap="square" lIns="0" tIns="0" rIns="0" bIns="0" rtlCol="0" anchor="ctr"/>
-          <a:lstStyle/>
-          <a:p>
-            <a:pPr indent="0" marL="0">
-              <a:buNone/>
-            </a:pPr>
-            <a:r>
-              <a:rPr lang="en-US" sz="1250" dirty="0">
-                <a:solidFill>
-                  <a:srgbClr val="C9BEAE"/>
-                </a:solidFill>
-                <a:latin typeface="Calibri" pitchFamily="34" charset="0"/>
-                <a:ea typeface="Calibri" pitchFamily="34" charset="-122"/>
-                <a:cs typeface="Calibri" pitchFamily="34" charset="-120"/>
-              </a:rPr>
-              <a:t>Materials and grain given room to speak for themselves.</a:t>
-            </a:r>
-            <a:endParaRPr lang="en-US" sz="1250" dirty="0"/>
-          </a:p>
-        </p:txBody>
-      </p:sp>
-      <p:sp>
-        <p:nvSpPr>
-          <p:cNvPr id="13" name="Text 11"/>
-          <p:cNvSpPr/>
-          <p:nvPr/>
-        </p:nvSpPr>
-        <p:spPr>
-          <a:xfrm>
-            <a:off x="914400" y="4297680"/>
-            <a:ext cx="5029200" cy="457200"/>
-          </a:xfrm>
-          <a:prstGeom prst="rect">
-            <a:avLst/>
-          </a:prstGeom>
-          <a:noFill/>
-          <a:ln/>
-        </p:spPr>
-        <p:txBody>
-          <a:bodyPr wrap="square" lIns="0" tIns="0" rIns="0" bIns="0" rtlCol="0" anchor="ctr"/>
-          <a:lstStyle/>
-          <a:p>
-            <a:pPr indent="0" marL="0">
-              <a:buNone/>
-            </a:pPr>
-            <a:r>
-              <a:rPr lang="en-US" sz="2400" i="1" dirty="0">
-                <a:solidFill>
-                  <a:srgbClr val="DFC58C"/>
-                </a:solidFill>
-                <a:latin typeface="Cambria" pitchFamily="34" charset="0"/>
-                <a:ea typeface="Cambria" pitchFamily="34" charset="-122"/>
-                <a:cs typeface="Cambria" pitchFamily="34" charset="-120"/>
-              </a:rPr>
-              <a:t>Considered</a:t>
-            </a:r>
-            <a:endParaRPr lang="en-US" sz="2400" dirty="0"/>
-          </a:p>
-        </p:txBody>
-      </p:sp>
-      <p:sp>
-        <p:nvSpPr>
-          <p:cNvPr id="14" name="Text 12"/>
-          <p:cNvSpPr/>
-          <p:nvPr/>
-        </p:nvSpPr>
-        <p:spPr>
-          <a:xfrm>
-            <a:off x="914400" y="4800600"/>
-            <a:ext cx="6035040" cy="457200"/>
-          </a:xfrm>
-          <a:prstGeom prst="rect">
-            <a:avLst/>
-          </a:prstGeom>
-          <a:noFill/>
-          <a:ln/>
-        </p:spPr>
-        <p:txBody>
-          <a:bodyPr wrap="square" lIns="0" tIns="0" rIns="0" bIns="0" rtlCol="0" anchor="ctr"/>
-          <a:lstStyle/>
-          <a:p>
-            <a:pPr indent="0" marL="0">
-              <a:buNone/>
-            </a:pPr>
-            <a:r>
-              <a:rPr lang="en-US" sz="1250" dirty="0">
-                <a:solidFill>
-                  <a:srgbClr val="C9BEAE"/>
-                </a:solidFill>
-                <a:latin typeface="Calibri" pitchFamily="34" charset="0"/>
-                <a:ea typeface="Calibri" pitchFamily="34" charset="-122"/>
-                <a:cs typeface="Calibri" pitchFamily="34" charset="-120"/>
-              </a:rPr>
-              <a:t>Every composition earns its whitespace.</a:t>
-            </a:r>
-            <a:endParaRPr lang="en-US" sz="1250" dirty="0"/>
-          </a:p>
-        </p:txBody>
-      </p:sp>
-      <p:sp>
-        <p:nvSpPr>
-          <p:cNvPr id="15" name="Text 13"/>
-          <p:cNvSpPr/>
-          <p:nvPr/>
-        </p:nvSpPr>
-        <p:spPr>
-          <a:xfrm>
-            <a:off x="914400" y="5623560"/>
-            <a:ext cx="6126480" cy="548640"/>
-          </a:xfrm>
-          <a:prstGeom prst="rect">
-            <a:avLst/>
-          </a:prstGeom>
-          <a:noFill/>
-          <a:ln/>
-        </p:spPr>
-        <p:txBody>
-          <a:bodyPr wrap="square" rtlCol="0" anchor="ctr"/>
-          <a:lstStyle/>
-          <a:p>
-            <a:pPr indent="0" marL="0">
-              <a:buNone/>
-            </a:pPr>
-            <a:r>
-              <a:rPr lang="en-US" sz="1150" i="1" dirty="0">
-                <a:solidFill>
-                  <a:srgbClr val="9A9086"/>
-                </a:solidFill>
-                <a:latin typeface="Calibri" pitchFamily="34" charset="0"/>
-                <a:ea typeface="Calibri" pitchFamily="34" charset="-122"/>
-                <a:cs typeface="Calibri" pitchFamily="34" charset="-120"/>
-              </a:rPr>
-              <a:t>Interiors photographed in soft, natural light — never staged, always lived-in.</a:t>
-            </a:r>
-            <a:endParaRPr lang="en-US" sz="1150" dirty="0"/>
           </a:p>
         </p:txBody>
       </p:sp>

</xml_diff>

<commit_message>
Client handover: PPT fixes, brand guide consistency, logo update
Brand guide (public/brand-guide.html):
- Header sub-line: vencoredesign.com · Astro 6 static site · public/brand-guide.html
- Footer: Vencore Design Co. → Vencore Design LLP
- Typography example: "Design that delivers." → "Design. Build. Deliver."

PPT (Vencore-Brand-Reference.pptx):
- Slide 1: docs/brand-guide.html → public/brand-guide.html
- Slide 2: pillars updated to Design / Build / Deliver with new descriptions
- Slide 4: "Design that delivers." → "Design. Build. Deliver."
- Slide 10 (Contact): Vencore Design Co. → Vencore Design LLP

Nav / Logo:
- logo-white.png regenerated from new transparent logo.png (1832×732)
- Nav dimensions updated to match new logo

Co-Authored-By: Claude Sonnet 4.6 <noreply@anthropic.com>
</commit_message>
<xml_diff>
--- a/public/Vencore-Brand-Reference.pptx
+++ b/public/Vencore-Brand-Reference.pptx
@@ -2060,7 +2060,7 @@
                 <a:ea typeface="Calibri" pitchFamily="34" charset="-122"/>
                 <a:cs typeface="Calibri" pitchFamily="34" charset="-120"/>
               </a:rPr>
-              <a:t>Astro 6  ·  docs/brand-guide.html</a:t>
+              <a:t>Astro 6  ·  public/brand-guide.html</a:t>
             </a:r>
             <a:endParaRPr lang="en-US" sz="1100" dirty="0"/>
           </a:p>
@@ -3445,7 +3445,7 @@
                 <ns1:ea typeface="Cambria" pitchFamily="34" charset="-122"/>
                 <ns1:cs typeface="Cambria" pitchFamily="34" charset="-120"/>
               </ns1:rPr>
-              <ns1:t>Vencore Design Co.</ns1:t>
+              <ns1:t>Vencore Design LLP</ns1:t>
             </ns1:r>
             <ns1:endParaRPr lang="en-US" sz="4000" dirty="0"/>
           </ns1:p>
@@ -4039,7 +4039,7 @@
                 <a:ea typeface="Cambria" pitchFamily="34" charset="-122"/>
                 <a:cs typeface="Cambria" pitchFamily="34" charset="-120"/>
               </a:rPr>
-              <a:t>Design that</a:t>
+              <a:t>Design.</a:t>
             </a:r>
             <a:endParaRPr lang="en-US" sz="4600" dirty="0"/>
           </a:p>
@@ -4059,7 +4059,7 @@
                 <a:ea typeface="Cambria" pitchFamily="34" charset="-122"/>
                 <a:cs typeface="Cambria" pitchFamily="34" charset="-120"/>
               </a:rPr>
-              <a:t>delivers.</a:t>
+              <a:t>Build. Deliver.</a:t>
             </a:r>
             <a:endParaRPr lang="en-US" sz="4600" dirty="0"/>
           </a:p>
@@ -4176,7 +4176,7 @@
                 <a:ea typeface="Cambria" pitchFamily="34" charset="-122"/>
                 <a:cs typeface="Cambria" pitchFamily="34" charset="-120"/>
               </a:rPr>
-              <a:t>Concept</a:t>
+              <a:t>Design</a:t>
             </a:r>
             <a:endParaRPr lang="en-US" sz="2200" dirty="0"/>
           </a:p>
@@ -4218,7 +4218,7 @@
                 <a:ea typeface="Calibri" pitchFamily="34" charset="-122"/>
                 <a:cs typeface="Calibri" pitchFamily="34" charset="-120"/>
               </a:rPr>
-              <a:t>Brief, brand, and building</a:t>
+              <a:t>Architecture, interiors,</a:t>
             </a:r>
             <a:endParaRPr lang="en-US" sz="1250" dirty="0"/>
           </a:p>
@@ -4238,7 +4238,7 @@
                 <a:ea typeface="Calibri" pitchFamily="34" charset="-122"/>
                 <a:cs typeface="Calibri" pitchFamily="34" charset="-120"/>
               </a:rPr>
-              <a:t>held in one conversation.</a:t>
+              <a:t>and procurement in one brief.</a:t>
             </a:r>
             <a:endParaRPr lang="en-US" sz="1250" dirty="0"/>
           </a:p>
@@ -4316,7 +4316,7 @@
                 <a:ea typeface="Cambria" pitchFamily="34" charset="-122"/>
                 <a:cs typeface="Cambria" pitchFamily="34" charset="-120"/>
               </a:rPr>
-              <a:t>Craft</a:t>
+              <a:t>Build</a:t>
             </a:r>
             <a:endParaRPr lang="en-US" sz="2200" dirty="0"/>
           </a:p>
@@ -4358,7 +4358,7 @@
                 <a:ea typeface="Calibri" pitchFamily="34" charset="-122"/>
                 <a:cs typeface="Calibri" pitchFamily="34" charset="-120"/>
               </a:rPr>
-              <a:t>Material, light, and detail,</a:t>
+              <a:t>Site execution owned</a:t>
             </a:r>
             <a:endParaRPr lang="en-US" sz="1250" dirty="0"/>
           </a:p>
@@ -4378,7 +4378,7 @@
                 <a:ea typeface="Calibri" pitchFamily="34" charset="-122"/>
                 <a:cs typeface="Calibri" pitchFamily="34" charset="-120"/>
               </a:rPr>
-              <a:t>resolved before site.</a:t>
+              <a:t>start to finish.</a:t>
             </a:r>
             <a:endParaRPr lang="en-US" sz="1250" dirty="0"/>
           </a:p>
@@ -4456,7 +4456,7 @@
                 <a:ea typeface="Cambria" pitchFamily="34" charset="-122"/>
                 <a:cs typeface="Cambria" pitchFamily="34" charset="-120"/>
               </a:rPr>
-              <a:t>Delivery</a:t>
+              <a:t>Deliver</a:t>
             </a:r>
             <a:endParaRPr lang="en-US" sz="2200" dirty="0"/>
           </a:p>
@@ -4498,7 +4498,7 @@
                 <a:ea typeface="Calibri" pitchFamily="34" charset="-122"/>
                 <a:cs typeface="Calibri" pitchFamily="34" charset="-120"/>
               </a:rPr>
-              <a:t>Turnkey execution, handed</a:t>
+              <a:t>One handover. Snagging-free,</a:t>
             </a:r>
             <a:endParaRPr lang="en-US" sz="1250" dirty="0"/>
           </a:p>
@@ -4518,7 +4518,7 @@
                 <a:ea typeface="Calibri" pitchFamily="34" charset="-122"/>
                 <a:cs typeface="Calibri" pitchFamily="34" charset="-120"/>
               </a:rPr>
-              <a:t>over once — done right.</a:t>
+              <a:t>client-ready spaces.</a:t>
             </a:r>
             <a:endParaRPr lang="en-US" sz="1250" dirty="0"/>
           </a:p>
@@ -6471,7 +6471,7 @@
                 <a:ea typeface="Cambria" pitchFamily="34" charset="-122"/>
                 <a:cs typeface="Cambria" pitchFamily="34" charset="-120"/>
               </a:rPr>
-              <a:t>“Design that delivers.”</a:t>
+              <a:t>“Design. Build. Deliver.”</a:t>
             </a:r>
             <a:endParaRPr lang="en-US" sz="1600" dirty="0"/>
           </a:p>

</xml_diff>